<commit_message>
Updated examples for project description
</commit_message>
<xml_diff>
--- a/Day1/Campus_to_Company.pptx
+++ b/Day1/Campus_to_Company.pptx
@@ -5,10 +5,10 @@
     <p:sldMasterId id="2147483648" r:id="rId1"/>
   </p:sldMasterIdLst>
   <p:notesMasterIdLst>
-    <p:notesMasterId r:id="rId34"/>
+    <p:notesMasterId r:id="rId36"/>
   </p:notesMasterIdLst>
   <p:handoutMasterIdLst>
-    <p:handoutMasterId r:id="rId35"/>
+    <p:handoutMasterId r:id="rId37"/>
   </p:handoutMasterIdLst>
   <p:sldIdLst>
     <p:sldId id="256" r:id="rId2"/>
@@ -39,54 +39,56 @@
     <p:sldId id="299" r:id="rId27"/>
     <p:sldId id="302" r:id="rId28"/>
     <p:sldId id="264" r:id="rId29"/>
-    <p:sldId id="295" r:id="rId30"/>
-    <p:sldId id="266" r:id="rId31"/>
-    <p:sldId id="267" r:id="rId32"/>
-    <p:sldId id="277" r:id="rId33"/>
+    <p:sldId id="303" r:id="rId30"/>
+    <p:sldId id="304" r:id="rId31"/>
+    <p:sldId id="295" r:id="rId32"/>
+    <p:sldId id="266" r:id="rId33"/>
+    <p:sldId id="267" r:id="rId34"/>
+    <p:sldId id="277" r:id="rId35"/>
   </p:sldIdLst>
   <p:sldSz cx="9144000" cy="5143500" type="screen16x9"/>
   <p:notesSz cx="6858000" cy="9144000"/>
   <p:embeddedFontLst>
     <p:embeddedFont>
       <p:font typeface="Arial Bold" panose="020B0704020202020204" pitchFamily="34" charset="0"/>
-      <p:bold r:id="rId36"/>
+      <p:bold r:id="rId38"/>
     </p:embeddedFont>
     <p:embeddedFont>
       <p:font typeface="DM Sans" pitchFamily="2" charset="0"/>
-      <p:regular r:id="rId37"/>
-      <p:bold r:id="rId38"/>
-      <p:italic r:id="rId39"/>
-      <p:boldItalic r:id="rId40"/>
+      <p:regular r:id="rId39"/>
+      <p:bold r:id="rId40"/>
+      <p:italic r:id="rId41"/>
+      <p:boldItalic r:id="rId42"/>
     </p:embeddedFont>
     <p:embeddedFont>
       <p:font typeface="DM Sans Medium" pitchFamily="2" charset="0"/>
-      <p:regular r:id="rId41"/>
-      <p:italic r:id="rId42"/>
+      <p:regular r:id="rId43"/>
+      <p:italic r:id="rId44"/>
     </p:embeddedFont>
     <p:embeddedFont>
       <p:font typeface="Inter" panose="020B0604020202020204" charset="0"/>
-      <p:regular r:id="rId43"/>
+      <p:regular r:id="rId45"/>
     </p:embeddedFont>
     <p:embeddedFont>
       <p:font typeface="Outfit" panose="020B0604020202020204" charset="0"/>
-      <p:regular r:id="rId44"/>
+      <p:regular r:id="rId46"/>
     </p:embeddedFont>
     <p:embeddedFont>
       <p:font typeface="Poppins" panose="00000500000000000000" pitchFamily="2" charset="0"/>
-      <p:regular r:id="rId45"/>
-      <p:bold r:id="rId46"/>
-      <p:italic r:id="rId47"/>
-      <p:boldItalic r:id="rId48"/>
+      <p:regular r:id="rId47"/>
+      <p:bold r:id="rId48"/>
+      <p:italic r:id="rId49"/>
+      <p:boldItalic r:id="rId50"/>
     </p:embeddedFont>
     <p:embeddedFont>
       <p:font typeface="Poppins ExtraBold" panose="00000900000000000000" pitchFamily="2" charset="0"/>
-      <p:bold r:id="rId49"/>
-      <p:boldItalic r:id="rId50"/>
+      <p:bold r:id="rId51"/>
+      <p:boldItalic r:id="rId52"/>
     </p:embeddedFont>
     <p:embeddedFont>
       <p:font typeface="Poppins SemiBold" panose="00000700000000000000" pitchFamily="2" charset="0"/>
-      <p:bold r:id="rId51"/>
-      <p:boldItalic r:id="rId52"/>
+      <p:bold r:id="rId53"/>
+      <p:boldItalic r:id="rId54"/>
     </p:embeddedFont>
   </p:embeddedFontLst>
   <p:defaultTextStyle>
@@ -419,7 +421,7 @@
           <a:p>
             <a:fld id="{696C064A-D61B-4B21-B757-51A9B82445B8}" type="datetimeFigureOut">
               <a:rPr lang="en-US" smtClean="0"/>
-              <a:t>04-Sep-26</a:t>
+              <a:t>06-Sep-26</a:t>
             </a:fld>
             <a:endParaRPr lang="en-US"/>
           </a:p>
@@ -2473,6 +2475,260 @@
   <p:cSld>
     <p:spTree>
       <p:nvGrpSpPr>
+        <p:cNvPr id="1" name="Shape 279">
+          <a:extLst>
+            <a:ext uri="{FF2B5EF4-FFF2-40B4-BE49-F238E27FC236}">
+              <a16:creationId xmlns:a16="http://schemas.microsoft.com/office/drawing/2014/main" id="{AFBBFFBE-1561-5D1B-917F-2656AE51B753}"/>
+            </a:ext>
+          </a:extLst>
+        </p:cNvPr>
+        <p:cNvGrpSpPr/>
+        <p:nvPr/>
+      </p:nvGrpSpPr>
+      <p:grpSpPr>
+        <a:xfrm>
+          <a:off x="0" y="0"/>
+          <a:ext cx="0" cy="0"/>
+          <a:chOff x="0" y="0"/>
+          <a:chExt cx="0" cy="0"/>
+        </a:xfrm>
+      </p:grpSpPr>
+      <p:sp>
+        <p:nvSpPr>
+          <p:cNvPr id="280" name="Google Shape;280;g3f2cca4355c_28_0:notes">
+            <a:extLst>
+              <a:ext uri="{FF2B5EF4-FFF2-40B4-BE49-F238E27FC236}">
+                <a16:creationId xmlns:a16="http://schemas.microsoft.com/office/drawing/2014/main" id="{539EDFB9-59A4-BCF8-0CF4-363A4E6AE9A8}"/>
+              </a:ext>
+            </a:extLst>
+          </p:cNvPr>
+          <p:cNvSpPr>
+            <a:spLocks noGrp="1" noRot="1" noChangeAspect="1"/>
+          </p:cNvSpPr>
+          <p:nvPr>
+            <p:ph type="sldImg" idx="2"/>
+          </p:nvPr>
+        </p:nvSpPr>
+        <p:spPr>
+          <a:xfrm>
+            <a:off x="381000" y="685800"/>
+            <a:ext cx="6096000" cy="3429000"/>
+          </a:xfrm>
+          <a:custGeom>
+            <a:avLst/>
+            <a:gdLst/>
+            <a:ahLst/>
+            <a:cxnLst/>
+            <a:rect l="l" t="t" r="r" b="b"/>
+            <a:pathLst>
+              <a:path w="120000" h="120000" extrusionOk="0">
+                <a:moveTo>
+                  <a:pt x="0" y="0"/>
+                </a:moveTo>
+                <a:lnTo>
+                  <a:pt x="120000" y="0"/>
+                </a:lnTo>
+                <a:lnTo>
+                  <a:pt x="120000" y="120000"/>
+                </a:lnTo>
+                <a:lnTo>
+                  <a:pt x="0" y="120000"/>
+                </a:lnTo>
+                <a:close/>
+              </a:path>
+            </a:pathLst>
+          </a:custGeom>
+        </p:spPr>
+      </p:sp>
+      <p:sp>
+        <p:nvSpPr>
+          <p:cNvPr id="281" name="Google Shape;281;g3f2cca4355c_28_0:notes">
+            <a:extLst>
+              <a:ext uri="{FF2B5EF4-FFF2-40B4-BE49-F238E27FC236}">
+                <a16:creationId xmlns:a16="http://schemas.microsoft.com/office/drawing/2014/main" id="{1EF39BCA-4461-77D8-E05D-B6FA97375D7D}"/>
+              </a:ext>
+            </a:extLst>
+          </p:cNvPr>
+          <p:cNvSpPr txBox="1">
+            <a:spLocks noGrp="1"/>
+          </p:cNvSpPr>
+          <p:nvPr>
+            <p:ph type="body" idx="1"/>
+          </p:nvPr>
+        </p:nvSpPr>
+        <p:spPr>
+          <a:xfrm>
+            <a:off x="685800" y="4343400"/>
+            <a:ext cx="5486400" cy="4114800"/>
+          </a:xfrm>
+          <a:prstGeom prst="rect">
+            <a:avLst/>
+          </a:prstGeom>
+        </p:spPr>
+        <p:txBody>
+          <a:bodyPr spcFirstLastPara="1" wrap="square" lIns="91425" tIns="91425" rIns="91425" bIns="91425" anchor="t" anchorCtr="0">
+            <a:noAutofit/>
+          </a:bodyPr>
+          <a:lstStyle/>
+          <a:p>
+            <a:pPr marL="0" lvl="0" indent="0" algn="l" rtl="0">
+              <a:spcBef>
+                <a:spcPts val="0"/>
+              </a:spcBef>
+              <a:spcAft>
+                <a:spcPts val="0"/>
+              </a:spcAft>
+              <a:buNone/>
+            </a:pPr>
+            <a:endParaRPr/>
+          </a:p>
+        </p:txBody>
+      </p:sp>
+    </p:spTree>
+    <p:extLst>
+      <p:ext uri="{BB962C8B-B14F-4D97-AF65-F5344CB8AC3E}">
+        <p14:creationId xmlns:p14="http://schemas.microsoft.com/office/powerpoint/2010/main" val="1331712012"/>
+      </p:ext>
+    </p:extLst>
+  </p:cSld>
+  <p:clrMapOvr>
+    <a:masterClrMapping/>
+  </p:clrMapOvr>
+</p:notes>
+</file>
+
+<file path=ppt/notesSlides/notesSlide23.xml><?xml version="1.0" encoding="utf-8"?>
+<p:notes xmlns:a="http://schemas.openxmlformats.org/drawingml/2006/main" xmlns:r="http://schemas.openxmlformats.org/officeDocument/2006/relationships" xmlns:p="http://schemas.openxmlformats.org/presentationml/2006/main" showMasterSp="0" showMasterPhAnim="0">
+  <p:cSld>
+    <p:spTree>
+      <p:nvGrpSpPr>
+        <p:cNvPr id="1" name="Shape 279">
+          <a:extLst>
+            <a:ext uri="{FF2B5EF4-FFF2-40B4-BE49-F238E27FC236}">
+              <a16:creationId xmlns:a16="http://schemas.microsoft.com/office/drawing/2014/main" id="{C950AC1D-4AEB-6208-7AE8-1998219C457F}"/>
+            </a:ext>
+          </a:extLst>
+        </p:cNvPr>
+        <p:cNvGrpSpPr/>
+        <p:nvPr/>
+      </p:nvGrpSpPr>
+      <p:grpSpPr>
+        <a:xfrm>
+          <a:off x="0" y="0"/>
+          <a:ext cx="0" cy="0"/>
+          <a:chOff x="0" y="0"/>
+          <a:chExt cx="0" cy="0"/>
+        </a:xfrm>
+      </p:grpSpPr>
+      <p:sp>
+        <p:nvSpPr>
+          <p:cNvPr id="280" name="Google Shape;280;g3f2cca4355c_28_0:notes">
+            <a:extLst>
+              <a:ext uri="{FF2B5EF4-FFF2-40B4-BE49-F238E27FC236}">
+                <a16:creationId xmlns:a16="http://schemas.microsoft.com/office/drawing/2014/main" id="{1C87B376-B086-6528-2770-321A719E84E6}"/>
+              </a:ext>
+            </a:extLst>
+          </p:cNvPr>
+          <p:cNvSpPr>
+            <a:spLocks noGrp="1" noRot="1" noChangeAspect="1"/>
+          </p:cNvSpPr>
+          <p:nvPr>
+            <p:ph type="sldImg" idx="2"/>
+          </p:nvPr>
+        </p:nvSpPr>
+        <p:spPr>
+          <a:xfrm>
+            <a:off x="381000" y="685800"/>
+            <a:ext cx="6096000" cy="3429000"/>
+          </a:xfrm>
+          <a:custGeom>
+            <a:avLst/>
+            <a:gdLst/>
+            <a:ahLst/>
+            <a:cxnLst/>
+            <a:rect l="l" t="t" r="r" b="b"/>
+            <a:pathLst>
+              <a:path w="120000" h="120000" extrusionOk="0">
+                <a:moveTo>
+                  <a:pt x="0" y="0"/>
+                </a:moveTo>
+                <a:lnTo>
+                  <a:pt x="120000" y="0"/>
+                </a:lnTo>
+                <a:lnTo>
+                  <a:pt x="120000" y="120000"/>
+                </a:lnTo>
+                <a:lnTo>
+                  <a:pt x="0" y="120000"/>
+                </a:lnTo>
+                <a:close/>
+              </a:path>
+            </a:pathLst>
+          </a:custGeom>
+        </p:spPr>
+      </p:sp>
+      <p:sp>
+        <p:nvSpPr>
+          <p:cNvPr id="281" name="Google Shape;281;g3f2cca4355c_28_0:notes">
+            <a:extLst>
+              <a:ext uri="{FF2B5EF4-FFF2-40B4-BE49-F238E27FC236}">
+                <a16:creationId xmlns:a16="http://schemas.microsoft.com/office/drawing/2014/main" id="{7230AEDF-39EF-40A8-FC0E-55D96626E983}"/>
+              </a:ext>
+            </a:extLst>
+          </p:cNvPr>
+          <p:cNvSpPr txBox="1">
+            <a:spLocks noGrp="1"/>
+          </p:cNvSpPr>
+          <p:nvPr>
+            <p:ph type="body" idx="1"/>
+          </p:nvPr>
+        </p:nvSpPr>
+        <p:spPr>
+          <a:xfrm>
+            <a:off x="685800" y="4343400"/>
+            <a:ext cx="5486400" cy="4114800"/>
+          </a:xfrm>
+          <a:prstGeom prst="rect">
+            <a:avLst/>
+          </a:prstGeom>
+        </p:spPr>
+        <p:txBody>
+          <a:bodyPr spcFirstLastPara="1" wrap="square" lIns="91425" tIns="91425" rIns="91425" bIns="91425" anchor="t" anchorCtr="0">
+            <a:noAutofit/>
+          </a:bodyPr>
+          <a:lstStyle/>
+          <a:p>
+            <a:pPr marL="0" lvl="0" indent="0" algn="l" rtl="0">
+              <a:spcBef>
+                <a:spcPts val="0"/>
+              </a:spcBef>
+              <a:spcAft>
+                <a:spcPts val="0"/>
+              </a:spcAft>
+              <a:buNone/>
+            </a:pPr>
+            <a:endParaRPr/>
+          </a:p>
+        </p:txBody>
+      </p:sp>
+    </p:spTree>
+    <p:extLst>
+      <p:ext uri="{BB962C8B-B14F-4D97-AF65-F5344CB8AC3E}">
+        <p14:creationId xmlns:p14="http://schemas.microsoft.com/office/powerpoint/2010/main" val="4036195641"/>
+      </p:ext>
+    </p:extLst>
+  </p:cSld>
+  <p:clrMapOvr>
+    <a:masterClrMapping/>
+  </p:clrMapOvr>
+</p:notes>
+</file>
+
+<file path=ppt/notesSlides/notesSlide24.xml><?xml version="1.0" encoding="utf-8"?>
+<p:notes xmlns:a="http://schemas.openxmlformats.org/drawingml/2006/main" xmlns:r="http://schemas.openxmlformats.org/officeDocument/2006/relationships" xmlns:p="http://schemas.openxmlformats.org/presentationml/2006/main" showMasterSp="0" showMasterPhAnim="0">
+  <p:cSld>
+    <p:spTree>
+      <p:nvGrpSpPr>
         <p:cNvPr id="1" name="Shape 282"/>
         <p:cNvGrpSpPr/>
         <p:nvPr/>
@@ -2572,7 +2828,7 @@
 </p:notes>
 </file>
 
-<file path=ppt/notesSlides/notesSlide23.xml><?xml version="1.0" encoding="utf-8"?>
+<file path=ppt/notesSlides/notesSlide25.xml><?xml version="1.0" encoding="utf-8"?>
 <p:notes xmlns:a="http://schemas.openxmlformats.org/drawingml/2006/main" xmlns:r="http://schemas.openxmlformats.org/officeDocument/2006/relationships" xmlns:p="http://schemas.openxmlformats.org/presentationml/2006/main" showMasterSp="0" showMasterPhAnim="0">
   <p:cSld>
     <p:spTree>
@@ -2676,7 +2932,7 @@
 </p:notes>
 </file>
 
-<file path=ppt/notesSlides/notesSlide24.xml><?xml version="1.0" encoding="utf-8"?>
+<file path=ppt/notesSlides/notesSlide26.xml><?xml version="1.0" encoding="utf-8"?>
 <p:notes xmlns:a="http://schemas.openxmlformats.org/drawingml/2006/main" xmlns:r="http://schemas.openxmlformats.org/officeDocument/2006/relationships" xmlns:p="http://schemas.openxmlformats.org/presentationml/2006/main" showMasterSp="0" showMasterPhAnim="0">
   <p:cSld>
     <p:spTree>
@@ -2780,7 +3036,7 @@
 </p:notes>
 </file>
 
-<file path=ppt/notesSlides/notesSlide25.xml><?xml version="1.0" encoding="utf-8"?>
+<file path=ppt/notesSlides/notesSlide27.xml><?xml version="1.0" encoding="utf-8"?>
 <p:notes xmlns:a="http://schemas.openxmlformats.org/drawingml/2006/main" xmlns:r="http://schemas.openxmlformats.org/officeDocument/2006/relationships" xmlns:p="http://schemas.openxmlformats.org/presentationml/2006/main" showMasterSp="0" showMasterPhAnim="0">
   <p:cSld>
     <p:spTree>
@@ -32120,6 +32376,1886 @@
 </file>
 
 <file path=ppt/slides/slide29.xml><?xml version="1.0" encoding="utf-8"?>
+<p:sld xmlns:a="http://schemas.openxmlformats.org/drawingml/2006/main" xmlns:r="http://schemas.openxmlformats.org/officeDocument/2006/relationships" xmlns:p="http://schemas.openxmlformats.org/presentationml/2006/main">
+  <p:cSld>
+    <p:spTree>
+      <p:nvGrpSpPr>
+        <p:cNvPr id="1" name="Shape 282">
+          <a:extLst>
+            <a:ext uri="{FF2B5EF4-FFF2-40B4-BE49-F238E27FC236}">
+              <a16:creationId xmlns:a16="http://schemas.microsoft.com/office/drawing/2014/main" id="{BEB9F8F9-5FC2-F199-D82A-1EC3ACE035FA}"/>
+            </a:ext>
+          </a:extLst>
+        </p:cNvPr>
+        <p:cNvGrpSpPr/>
+        <p:nvPr/>
+      </p:nvGrpSpPr>
+      <p:grpSpPr>
+        <a:xfrm>
+          <a:off x="0" y="0"/>
+          <a:ext cx="0" cy="0"/>
+          <a:chOff x="0" y="0"/>
+          <a:chExt cx="0" cy="0"/>
+        </a:xfrm>
+      </p:grpSpPr>
+      <p:sp>
+        <p:nvSpPr>
+          <p:cNvPr id="283" name="Google Shape;283;p22">
+            <a:extLst>
+              <a:ext uri="{FF2B5EF4-FFF2-40B4-BE49-F238E27FC236}">
+                <a16:creationId xmlns:a16="http://schemas.microsoft.com/office/drawing/2014/main" id="{7868FBB6-3E2E-78D3-9CDF-81699004679D}"/>
+              </a:ext>
+            </a:extLst>
+          </p:cNvPr>
+          <p:cNvSpPr/>
+          <p:nvPr/>
+        </p:nvSpPr>
+        <p:spPr>
+          <a:xfrm>
+            <a:off x="0" y="0"/>
+            <a:ext cx="9144000" cy="5143500"/>
+          </a:xfrm>
+          <a:prstGeom prst="rect">
+            <a:avLst/>
+          </a:prstGeom>
+          <a:solidFill>
+            <a:srgbClr val="F8F9FA"/>
+          </a:solidFill>
+          <a:ln>
+            <a:noFill/>
+          </a:ln>
+        </p:spPr>
+        <p:txBody>
+          <a:bodyPr spcFirstLastPara="1" wrap="square" lIns="0" tIns="0" rIns="0" bIns="0" anchor="ctr" anchorCtr="0">
+            <a:noAutofit/>
+          </a:bodyPr>
+          <a:lstStyle/>
+          <a:p>
+            <a:pPr marL="0" lvl="0" indent="0" algn="l" rtl="0">
+              <a:spcBef>
+                <a:spcPts val="0"/>
+              </a:spcBef>
+              <a:spcAft>
+                <a:spcPts val="0"/>
+              </a:spcAft>
+              <a:buNone/>
+            </a:pPr>
+            <a:endParaRPr/>
+          </a:p>
+        </p:txBody>
+      </p:sp>
+      <p:pic>
+        <p:nvPicPr>
+          <p:cNvPr id="80" name="Google Shape;80;p15">
+            <a:extLst>
+              <a:ext uri="{FF2B5EF4-FFF2-40B4-BE49-F238E27FC236}">
+                <a16:creationId xmlns:a16="http://schemas.microsoft.com/office/drawing/2014/main" id="{FD930803-13E7-F5F0-A435-C878E196C361}"/>
+              </a:ext>
+            </a:extLst>
+          </p:cNvPr>
+          <p:cNvPicPr preferRelativeResize="0"/>
+          <p:nvPr/>
+        </p:nvPicPr>
+        <p:blipFill rotWithShape="1">
+          <a:blip r:embed="rId3"/>
+          <a:srcRect/>
+          <a:stretch>
+            <a:fillRect/>
+          </a:stretch>
+        </p:blipFill>
+        <p:spPr>
+          <a:xfrm>
+            <a:off x="5080" y="5080"/>
+            <a:ext cx="9138920" cy="5139055"/>
+          </a:xfrm>
+          <a:prstGeom prst="rect">
+            <a:avLst/>
+          </a:prstGeom>
+          <a:noFill/>
+          <a:ln>
+            <a:noFill/>
+          </a:ln>
+        </p:spPr>
+      </p:pic>
+      <p:sp>
+        <p:nvSpPr>
+          <p:cNvPr id="284" name="Google Shape;284;p22">
+            <a:extLst>
+              <a:ext uri="{FF2B5EF4-FFF2-40B4-BE49-F238E27FC236}">
+                <a16:creationId xmlns:a16="http://schemas.microsoft.com/office/drawing/2014/main" id="{B7A5BE89-1919-59AD-CE48-1D737798C75D}"/>
+              </a:ext>
+            </a:extLst>
+          </p:cNvPr>
+          <p:cNvSpPr/>
+          <p:nvPr/>
+        </p:nvSpPr>
+        <p:spPr>
+          <a:xfrm>
+            <a:off x="0" y="0"/>
+            <a:ext cx="9144000" cy="76200"/>
+          </a:xfrm>
+          <a:prstGeom prst="rect">
+            <a:avLst/>
+          </a:prstGeom>
+          <a:solidFill>
+            <a:srgbClr val="2D68FE"/>
+          </a:solidFill>
+          <a:ln>
+            <a:noFill/>
+          </a:ln>
+        </p:spPr>
+        <p:txBody>
+          <a:bodyPr spcFirstLastPara="1" wrap="square" lIns="0" tIns="0" rIns="0" bIns="0" anchor="ctr" anchorCtr="0">
+            <a:noAutofit/>
+          </a:bodyPr>
+          <a:lstStyle/>
+          <a:p>
+            <a:pPr marL="0" lvl="0" indent="0" algn="l" rtl="0">
+              <a:spcBef>
+                <a:spcPts val="0"/>
+              </a:spcBef>
+              <a:spcAft>
+                <a:spcPts val="0"/>
+              </a:spcAft>
+              <a:buNone/>
+            </a:pPr>
+            <a:endParaRPr/>
+          </a:p>
+        </p:txBody>
+      </p:sp>
+      <p:pic>
+        <p:nvPicPr>
+          <p:cNvPr id="286" name="Google Shape;286;p22">
+            <a:extLst>
+              <a:ext uri="{FF2B5EF4-FFF2-40B4-BE49-F238E27FC236}">
+                <a16:creationId xmlns:a16="http://schemas.microsoft.com/office/drawing/2014/main" id="{67E200AB-6FA9-4E9E-4504-633CAEEB9644}"/>
+              </a:ext>
+            </a:extLst>
+          </p:cNvPr>
+          <p:cNvPicPr preferRelativeResize="0"/>
+          <p:nvPr/>
+        </p:nvPicPr>
+        <p:blipFill rotWithShape="1">
+          <a:blip r:embed="rId4"/>
+          <a:srcRect/>
+          <a:stretch>
+            <a:fillRect/>
+          </a:stretch>
+        </p:blipFill>
+        <p:spPr>
+          <a:xfrm>
+            <a:off x="6848475" y="847725"/>
+            <a:ext cx="2276400" cy="3448200"/>
+          </a:xfrm>
+          <a:prstGeom prst="rect">
+            <a:avLst/>
+          </a:prstGeom>
+          <a:noFill/>
+          <a:ln>
+            <a:noFill/>
+          </a:ln>
+        </p:spPr>
+      </p:pic>
+      <p:sp>
+        <p:nvSpPr>
+          <p:cNvPr id="288" name="Google Shape;288;p22">
+            <a:extLst>
+              <a:ext uri="{FF2B5EF4-FFF2-40B4-BE49-F238E27FC236}">
+                <a16:creationId xmlns:a16="http://schemas.microsoft.com/office/drawing/2014/main" id="{271AC1B7-82E4-E79C-D6DF-206957CB409F}"/>
+              </a:ext>
+            </a:extLst>
+          </p:cNvPr>
+          <p:cNvSpPr txBox="1"/>
+          <p:nvPr/>
+        </p:nvSpPr>
+        <p:spPr>
+          <a:xfrm>
+            <a:off x="571500" y="381000"/>
+            <a:ext cx="8001000" cy="1047900"/>
+          </a:xfrm>
+          <a:prstGeom prst="rect">
+            <a:avLst/>
+          </a:prstGeom>
+          <a:solidFill>
+            <a:srgbClr val="000000">
+              <a:alpha val="0"/>
+            </a:srgbClr>
+          </a:solidFill>
+          <a:ln>
+            <a:noFill/>
+          </a:ln>
+        </p:spPr>
+        <p:txBody>
+          <a:bodyPr spcFirstLastPara="1" wrap="square" lIns="0" tIns="0" rIns="0" bIns="0" anchor="t" anchorCtr="0">
+            <a:noAutofit/>
+          </a:bodyPr>
+          <a:lstStyle/>
+          <a:p>
+            <a:pPr marL="0" lvl="0" indent="0" algn="l" rtl="0">
+              <a:spcBef>
+                <a:spcPts val="0"/>
+              </a:spcBef>
+              <a:spcAft>
+                <a:spcPts val="0"/>
+              </a:spcAft>
+              <a:buNone/>
+            </a:pPr>
+            <a:r>
+              <a:rPr lang="en-GB" sz="1800" b="1" i="0" u="none" strike="noStrike" dirty="0">
+                <a:solidFill>
+                  <a:srgbClr val="FF5733"/>
+                </a:solidFill>
+                <a:latin typeface="Poppins" panose="00000800000000000000"/>
+                <a:ea typeface="Poppins" panose="00000800000000000000"/>
+                <a:cs typeface="Poppins" panose="00000800000000000000"/>
+                <a:sym typeface="Poppins" panose="00000800000000000000"/>
+              </a:rPr>
+              <a:t>RESUME STRATEGY</a:t>
+            </a:r>
+            <a:endParaRPr sz="1800" b="1" i="0" u="none" strike="noStrike" dirty="0">
+              <a:solidFill>
+                <a:srgbClr val="FF5733"/>
+              </a:solidFill>
+              <a:latin typeface="Poppins" panose="00000800000000000000"/>
+              <a:ea typeface="Poppins" panose="00000800000000000000"/>
+              <a:cs typeface="Poppins" panose="00000800000000000000"/>
+              <a:sym typeface="Poppins" panose="00000800000000000000"/>
+            </a:endParaRPr>
+          </a:p>
+          <a:p>
+            <a:pPr marL="0" lvl="0" indent="0" algn="l" rtl="0">
+              <a:spcBef>
+                <a:spcPts val="600"/>
+              </a:spcBef>
+              <a:spcAft>
+                <a:spcPts val="600"/>
+              </a:spcAft>
+              <a:buNone/>
+            </a:pPr>
+            <a:r>
+              <a:rPr lang="en-GB" sz="2700" b="0" i="0" u="none" strike="noStrike" dirty="0">
+                <a:solidFill>
+                  <a:srgbClr val="0B132B"/>
+                </a:solidFill>
+                <a:latin typeface="Poppins SemiBold"/>
+                <a:ea typeface="Poppins SemiBold"/>
+                <a:cs typeface="Poppins SemiBold"/>
+                <a:sym typeface="Poppins SemiBold"/>
+              </a:rPr>
+              <a:t>Showcasing Your Projects for Impact</a:t>
+            </a:r>
+            <a:endParaRPr sz="1800" b="1" i="0" u="none" strike="noStrike" dirty="0">
+              <a:solidFill>
+                <a:srgbClr val="FF5733"/>
+              </a:solidFill>
+              <a:latin typeface="Poppins" panose="00000800000000000000"/>
+              <a:ea typeface="Poppins" panose="00000800000000000000"/>
+              <a:cs typeface="Poppins" panose="00000800000000000000"/>
+              <a:sym typeface="Poppins" panose="00000800000000000000"/>
+            </a:endParaRPr>
+          </a:p>
+        </p:txBody>
+      </p:sp>
+      <p:cxnSp>
+        <p:nvCxnSpPr>
+          <p:cNvPr id="93" name="Google Shape;93;p15">
+            <a:extLst>
+              <a:ext uri="{FF2B5EF4-FFF2-40B4-BE49-F238E27FC236}">
+                <a16:creationId xmlns:a16="http://schemas.microsoft.com/office/drawing/2014/main" id="{668D8B42-E030-0104-E32F-D2BE9255FE0F}"/>
+              </a:ext>
+            </a:extLst>
+          </p:cNvPr>
+          <p:cNvCxnSpPr/>
+          <p:nvPr/>
+        </p:nvCxnSpPr>
+        <p:spPr>
+          <a:xfrm>
+            <a:off x="311785" y="1333500"/>
+            <a:ext cx="8382000" cy="0"/>
+          </a:xfrm>
+          <a:prstGeom prst="straightConnector1">
+            <a:avLst/>
+          </a:prstGeom>
+          <a:solidFill>
+            <a:srgbClr val="FFFFFF"/>
+          </a:solidFill>
+          <a:ln w="38100" cap="flat" cmpd="sng">
+            <a:solidFill>
+              <a:srgbClr val="111827"/>
+            </a:solidFill>
+            <a:prstDash val="solid"/>
+            <a:round/>
+            <a:headEnd type="none" w="sm" len="sm"/>
+            <a:tailEnd type="none" w="sm" len="sm"/>
+          </a:ln>
+        </p:spPr>
+      </p:cxnSp>
+      <p:sp>
+        <p:nvSpPr>
+          <p:cNvPr id="7" name="TextBox 6">
+            <a:extLst>
+              <a:ext uri="{FF2B5EF4-FFF2-40B4-BE49-F238E27FC236}">
+                <a16:creationId xmlns:a16="http://schemas.microsoft.com/office/drawing/2014/main" id="{B6FB9C18-1709-DBB5-DC3F-1F060C8BADAC}"/>
+              </a:ext>
+            </a:extLst>
+          </p:cNvPr>
+          <p:cNvSpPr txBox="1"/>
+          <p:nvPr/>
+        </p:nvSpPr>
+        <p:spPr>
+          <a:xfrm>
+            <a:off x="371437" y="1560709"/>
+            <a:ext cx="8401125" cy="1384995"/>
+          </a:xfrm>
+          <a:prstGeom prst="rect">
+            <a:avLst/>
+          </a:prstGeom>
+          <a:noFill/>
+        </p:spPr>
+        <p:txBody>
+          <a:bodyPr wrap="square">
+            <a:spAutoFit/>
+          </a:bodyPr>
+          <a:lstStyle/>
+          <a:p>
+            <a:pPr>
+              <a:buNone/>
+            </a:pPr>
+            <a:r>
+              <a:rPr lang="en-US" b="1" dirty="0"/>
+              <a:t>Online Book Store Project – Typical Version</a:t>
+            </a:r>
+          </a:p>
+          <a:p>
+            <a:pPr>
+              <a:buNone/>
+            </a:pPr>
+            <a:endParaRPr lang="en-US" b="1" dirty="0"/>
+          </a:p>
+          <a:p>
+            <a:pPr>
+              <a:buNone/>
+            </a:pPr>
+            <a:r>
+              <a:rPr lang="en-US" dirty="0"/>
+              <a:t>Developed an online book store web application where users can register, login, get books. The application also includes an admin module. Worked on database design, user modules, cart functionality and payment integration using HTML, CSS, JavaScript, React, Node.js, Express.js and MySQL. The application reduced the average book-search time by approximately 60% during testing.</a:t>
+            </a:r>
+          </a:p>
+        </p:txBody>
+      </p:sp>
+      <p:sp>
+        <p:nvSpPr>
+          <p:cNvPr id="8" name="TextBox 7">
+            <a:extLst>
+              <a:ext uri="{FF2B5EF4-FFF2-40B4-BE49-F238E27FC236}">
+                <a16:creationId xmlns:a16="http://schemas.microsoft.com/office/drawing/2014/main" id="{905CF1FA-2BDB-5093-BCEB-9446BEB24409}"/>
+              </a:ext>
+            </a:extLst>
+          </p:cNvPr>
+          <p:cNvSpPr txBox="1"/>
+          <p:nvPr/>
+        </p:nvSpPr>
+        <p:spPr>
+          <a:xfrm>
+            <a:off x="302222" y="3165233"/>
+            <a:ext cx="8401125" cy="1384995"/>
+          </a:xfrm>
+          <a:prstGeom prst="rect">
+            <a:avLst/>
+          </a:prstGeom>
+          <a:noFill/>
+        </p:spPr>
+        <p:txBody>
+          <a:bodyPr wrap="square">
+            <a:spAutoFit/>
+          </a:bodyPr>
+          <a:lstStyle/>
+          <a:p>
+            <a:pPr>
+              <a:buNone/>
+            </a:pPr>
+            <a:r>
+              <a:rPr lang="en-US" b="1" dirty="0"/>
+              <a:t>Online Book Store Project – Improved, Impact-Focused Version</a:t>
+            </a:r>
+          </a:p>
+          <a:p>
+            <a:pPr>
+              <a:buNone/>
+            </a:pPr>
+            <a:endParaRPr lang="en-US" b="1" dirty="0"/>
+          </a:p>
+          <a:p>
+            <a:pPr>
+              <a:buNone/>
+            </a:pPr>
+            <a:r>
+              <a:rPr lang="en-US" dirty="0"/>
+              <a:t>Built an online bookstore for ABC School to simplify search and issue of books to their students. As a </a:t>
+            </a:r>
+            <a:r>
+              <a:rPr lang="en-US" b="1" dirty="0"/>
+              <a:t>Full Stack Developer</a:t>
+            </a:r>
+            <a:r>
+              <a:rPr lang="en-US" dirty="0"/>
+              <a:t>, developed the search, filtering, cart and online payment functionality using </a:t>
+            </a:r>
+            <a:r>
+              <a:rPr lang="en-US" b="1" dirty="0"/>
+              <a:t>React, Node.js and MySQL</a:t>
+            </a:r>
+            <a:r>
+              <a:rPr lang="en-US" dirty="0"/>
+              <a:t>. The application supported </a:t>
+            </a:r>
+            <a:r>
+              <a:rPr lang="en-US" b="1" dirty="0"/>
+              <a:t>1000+ books </a:t>
+            </a:r>
+            <a:r>
+              <a:rPr lang="en-US" dirty="0"/>
+              <a:t>and has currently serviced </a:t>
+            </a:r>
+            <a:r>
+              <a:rPr lang="en-US" b="1" dirty="0"/>
+              <a:t>1800 students in a 3-month </a:t>
+            </a:r>
+            <a:r>
+              <a:rPr lang="en-US" dirty="0"/>
+              <a:t>period.</a:t>
+            </a:r>
+          </a:p>
+        </p:txBody>
+      </p:sp>
+    </p:spTree>
+    <p:extLst>
+      <p:ext uri="{BB962C8B-B14F-4D97-AF65-F5344CB8AC3E}">
+        <p14:creationId xmlns:p14="http://schemas.microsoft.com/office/powerpoint/2010/main" val="933955087"/>
+      </p:ext>
+    </p:extLst>
+  </p:cSld>
+  <p:clrMapOvr>
+    <a:masterClrMapping/>
+  </p:clrMapOvr>
+  <p:timing>
+    <p:tnLst>
+      <p:par>
+        <p:cTn id="1" dur="indefinite" restart="never" nodeType="tmRoot">
+          <p:childTnLst>
+            <p:seq concurrent="1" nextAc="seek">
+              <p:cTn id="2" dur="indefinite" nodeType="mainSeq">
+                <p:childTnLst>
+                  <p:par>
+                    <p:cTn id="3" fill="hold">
+                      <p:stCondLst>
+                        <p:cond delay="indefinite"/>
+                      </p:stCondLst>
+                      <p:childTnLst>
+                        <p:par>
+                          <p:cTn id="4" fill="hold">
+                            <p:stCondLst>
+                              <p:cond delay="0"/>
+                            </p:stCondLst>
+                            <p:childTnLst>
+                              <p:par>
+                                <p:cTn id="5" presetID="1" presetClass="entr" presetSubtype="0" fill="hold" grpId="0" nodeType="clickEffect">
+                                  <p:stCondLst>
+                                    <p:cond delay="0"/>
+                                  </p:stCondLst>
+                                  <p:childTnLst>
+                                    <p:set>
+                                      <p:cBhvr>
+                                        <p:cTn id="6" dur="1" fill="hold">
+                                          <p:stCondLst>
+                                            <p:cond delay="0"/>
+                                          </p:stCondLst>
+                                        </p:cTn>
+                                        <p:tgtEl>
+                                          <p:spTgt spid="7"/>
+                                        </p:tgtEl>
+                                        <p:attrNameLst>
+                                          <p:attrName>style.visibility</p:attrName>
+                                        </p:attrNameLst>
+                                      </p:cBhvr>
+                                      <p:to>
+                                        <p:strVal val="visible"/>
+                                      </p:to>
+                                    </p:set>
+                                  </p:childTnLst>
+                                </p:cTn>
+                              </p:par>
+                            </p:childTnLst>
+                          </p:cTn>
+                        </p:par>
+                      </p:childTnLst>
+                    </p:cTn>
+                  </p:par>
+                  <p:par>
+                    <p:cTn id="7" fill="hold">
+                      <p:stCondLst>
+                        <p:cond delay="indefinite"/>
+                      </p:stCondLst>
+                      <p:childTnLst>
+                        <p:par>
+                          <p:cTn id="8" fill="hold">
+                            <p:stCondLst>
+                              <p:cond delay="0"/>
+                            </p:stCondLst>
+                            <p:childTnLst>
+                              <p:par>
+                                <p:cTn id="9" presetID="1" presetClass="entr" presetSubtype="0" fill="hold" grpId="0" nodeType="clickEffect">
+                                  <p:stCondLst>
+                                    <p:cond delay="0"/>
+                                  </p:stCondLst>
+                                  <p:childTnLst>
+                                    <p:set>
+                                      <p:cBhvr>
+                                        <p:cTn id="10" dur="1" fill="hold">
+                                          <p:stCondLst>
+                                            <p:cond delay="0"/>
+                                          </p:stCondLst>
+                                        </p:cTn>
+                                        <p:tgtEl>
+                                          <p:spTgt spid="8"/>
+                                        </p:tgtEl>
+                                        <p:attrNameLst>
+                                          <p:attrName>style.visibility</p:attrName>
+                                        </p:attrNameLst>
+                                      </p:cBhvr>
+                                      <p:to>
+                                        <p:strVal val="visible"/>
+                                      </p:to>
+                                    </p:set>
+                                  </p:childTnLst>
+                                </p:cTn>
+                              </p:par>
+                            </p:childTnLst>
+                          </p:cTn>
+                        </p:par>
+                      </p:childTnLst>
+                    </p:cTn>
+                  </p:par>
+                </p:childTnLst>
+              </p:cTn>
+              <p:prevCondLst>
+                <p:cond evt="onPrev" delay="0">
+                  <p:tgtEl>
+                    <p:sldTgt/>
+                  </p:tgtEl>
+                </p:cond>
+              </p:prevCondLst>
+              <p:nextCondLst>
+                <p:cond evt="onNext" delay="0">
+                  <p:tgtEl>
+                    <p:sldTgt/>
+                  </p:tgtEl>
+                </p:cond>
+              </p:nextCondLst>
+            </p:seq>
+          </p:childTnLst>
+        </p:cTn>
+      </p:par>
+    </p:tnLst>
+    <p:bldLst>
+      <p:bldP spid="7" grpId="0"/>
+      <p:bldP spid="8" grpId="0"/>
+    </p:bldLst>
+  </p:timing>
+</p:sld>
+</file>
+
+<file path=ppt/slides/slide3.xml><?xml version="1.0" encoding="utf-8"?>
+<p:sld xmlns:a="http://schemas.openxmlformats.org/drawingml/2006/main" xmlns:r="http://schemas.openxmlformats.org/officeDocument/2006/relationships" xmlns:p="http://schemas.openxmlformats.org/presentationml/2006/main">
+  <p:cSld>
+    <p:spTree>
+      <p:nvGrpSpPr>
+        <p:cNvPr id="1" name=""/>
+        <p:cNvGrpSpPr/>
+        <p:nvPr/>
+      </p:nvGrpSpPr>
+      <p:grpSpPr>
+        <a:xfrm>
+          <a:off x="0" y="0"/>
+          <a:ext cx="0" cy="0"/>
+          <a:chOff x="0" y="0"/>
+          <a:chExt cx="0" cy="0"/>
+        </a:xfrm>
+      </p:grpSpPr>
+      <p:grpSp>
+        <p:nvGrpSpPr>
+          <p:cNvPr id="78" name="Google Shape;78;p15"/>
+          <p:cNvGrpSpPr/>
+          <p:nvPr/>
+        </p:nvGrpSpPr>
+        <p:grpSpPr>
+          <a:xfrm>
+            <a:off x="0" y="0"/>
+            <a:ext cx="9144150" cy="5143650"/>
+            <a:chOff x="0" y="0"/>
+            <a:chExt cx="9144150" cy="5143650"/>
+          </a:xfrm>
+        </p:grpSpPr>
+        <p:sp>
+          <p:nvSpPr>
+            <p:cNvPr id="79" name="Google Shape;79;p15"/>
+            <p:cNvSpPr/>
+            <p:nvPr/>
+          </p:nvSpPr>
+          <p:spPr>
+            <a:xfrm>
+              <a:off x="0" y="0"/>
+              <a:ext cx="9144000" cy="5143500"/>
+            </a:xfrm>
+            <a:prstGeom prst="rect">
+              <a:avLst/>
+            </a:prstGeom>
+            <a:solidFill>
+              <a:srgbClr val="F8F9FA"/>
+            </a:solidFill>
+            <a:ln>
+              <a:noFill/>
+            </a:ln>
+          </p:spPr>
+          <p:txBody>
+            <a:bodyPr spcFirstLastPara="1" wrap="square" lIns="0" tIns="0" rIns="0" bIns="0" anchor="ctr" anchorCtr="0">
+              <a:noAutofit/>
+            </a:bodyPr>
+            <a:lstStyle/>
+            <a:p>
+              <a:pPr marL="0" lvl="0" indent="0" algn="l" rtl="0">
+                <a:spcBef>
+                  <a:spcPts val="0"/>
+                </a:spcBef>
+                <a:spcAft>
+                  <a:spcPts val="0"/>
+                </a:spcAft>
+                <a:buNone/>
+              </a:pPr>
+              <a:endParaRPr/>
+            </a:p>
+          </p:txBody>
+        </p:sp>
+        <p:pic>
+          <p:nvPicPr>
+            <p:cNvPr id="80" name="Google Shape;80;p15"/>
+            <p:cNvPicPr preferRelativeResize="0"/>
+            <p:nvPr/>
+          </p:nvPicPr>
+          <p:blipFill rotWithShape="1">
+            <a:blip r:embed="rId2"/>
+            <a:srcRect/>
+            <a:stretch>
+              <a:fillRect/>
+            </a:stretch>
+          </p:blipFill>
+          <p:spPr>
+            <a:xfrm>
+              <a:off x="4763" y="4763"/>
+              <a:ext cx="8982000" cy="4981500"/>
+            </a:xfrm>
+            <a:prstGeom prst="rect">
+              <a:avLst/>
+            </a:prstGeom>
+            <a:noFill/>
+            <a:ln>
+              <a:noFill/>
+            </a:ln>
+          </p:spPr>
+        </p:pic>
+        <p:sp>
+          <p:nvSpPr>
+            <p:cNvPr id="81" name="Google Shape;81;p15"/>
+            <p:cNvSpPr/>
+            <p:nvPr/>
+          </p:nvSpPr>
+          <p:spPr>
+            <a:xfrm>
+              <a:off x="0" y="0"/>
+              <a:ext cx="9144000" cy="76200"/>
+            </a:xfrm>
+            <a:prstGeom prst="rect">
+              <a:avLst/>
+            </a:prstGeom>
+            <a:solidFill>
+              <a:srgbClr val="2D68FE"/>
+            </a:solidFill>
+            <a:ln>
+              <a:noFill/>
+            </a:ln>
+          </p:spPr>
+          <p:txBody>
+            <a:bodyPr spcFirstLastPara="1" wrap="square" lIns="0" tIns="0" rIns="0" bIns="0" anchor="ctr" anchorCtr="0">
+              <a:noAutofit/>
+            </a:bodyPr>
+            <a:lstStyle/>
+            <a:p>
+              <a:pPr marL="0" lvl="0" indent="0" algn="l" rtl="0">
+                <a:spcBef>
+                  <a:spcPts val="0"/>
+                </a:spcBef>
+                <a:spcAft>
+                  <a:spcPts val="0"/>
+                </a:spcAft>
+                <a:buNone/>
+              </a:pPr>
+              <a:endParaRPr/>
+            </a:p>
+          </p:txBody>
+        </p:sp>
+        <p:sp>
+          <p:nvSpPr>
+            <p:cNvPr id="82" name="Google Shape;82;p15"/>
+            <p:cNvSpPr/>
+            <p:nvPr/>
+          </p:nvSpPr>
+          <p:spPr>
+            <a:xfrm>
+              <a:off x="8477250" y="4476750"/>
+              <a:ext cx="666900" cy="666900"/>
+            </a:xfrm>
+            <a:custGeom>
+              <a:avLst/>
+              <a:gdLst/>
+              <a:ahLst/>
+              <a:cxnLst/>
+              <a:rect l="l" t="t" r="r" b="b"/>
+              <a:pathLst>
+                <a:path w="120000" h="120000" extrusionOk="0">
+                  <a:moveTo>
+                    <a:pt x="120000" y="120000"/>
+                  </a:moveTo>
+                  <a:lnTo>
+                    <a:pt x="120000" y="0"/>
+                  </a:lnTo>
+                  <a:lnTo>
+                    <a:pt x="0" y="120000"/>
+                  </a:lnTo>
+                  <a:close/>
+                </a:path>
+              </a:pathLst>
+            </a:custGeom>
+            <a:solidFill>
+              <a:srgbClr val="FFC300">
+                <a:alpha val="69999"/>
+              </a:srgbClr>
+            </a:solidFill>
+            <a:ln>
+              <a:noFill/>
+            </a:ln>
+          </p:spPr>
+          <p:txBody>
+            <a:bodyPr spcFirstLastPara="1" wrap="square" lIns="0" tIns="0" rIns="0" bIns="0" anchor="ctr" anchorCtr="0">
+              <a:noAutofit/>
+            </a:bodyPr>
+            <a:lstStyle/>
+            <a:p>
+              <a:pPr marL="0" lvl="0" indent="0" algn="l" rtl="0">
+                <a:spcBef>
+                  <a:spcPts val="0"/>
+                </a:spcBef>
+                <a:spcAft>
+                  <a:spcPts val="0"/>
+                </a:spcAft>
+                <a:buNone/>
+              </a:pPr>
+              <a:endParaRPr/>
+            </a:p>
+          </p:txBody>
+        </p:sp>
+      </p:grpSp>
+      <p:pic>
+        <p:nvPicPr>
+          <p:cNvPr id="6" name="Picture 5"/>
+          <p:cNvPicPr>
+            <a:picLocks noChangeAspect="1"/>
+          </p:cNvPicPr>
+          <p:nvPr/>
+        </p:nvPicPr>
+        <p:blipFill>
+          <a:blip r:embed="rId3"/>
+          <a:stretch>
+            <a:fillRect/>
+          </a:stretch>
+        </p:blipFill>
+        <p:spPr>
+          <a:xfrm>
+            <a:off x="562531" y="1551094"/>
+            <a:ext cx="1781424" cy="1714739"/>
+          </a:xfrm>
+          <a:prstGeom prst="rect">
+            <a:avLst/>
+          </a:prstGeom>
+        </p:spPr>
+      </p:pic>
+      <p:pic>
+        <p:nvPicPr>
+          <p:cNvPr id="8" name="Picture 7"/>
+          <p:cNvPicPr>
+            <a:picLocks noChangeAspect="1"/>
+          </p:cNvPicPr>
+          <p:nvPr/>
+        </p:nvPicPr>
+        <p:blipFill>
+          <a:blip r:embed="rId4"/>
+          <a:stretch>
+            <a:fillRect/>
+          </a:stretch>
+        </p:blipFill>
+        <p:spPr>
+          <a:xfrm>
+            <a:off x="2629457" y="1512988"/>
+            <a:ext cx="1762371" cy="1752845"/>
+          </a:xfrm>
+          <a:prstGeom prst="rect">
+            <a:avLst/>
+          </a:prstGeom>
+        </p:spPr>
+      </p:pic>
+      <p:pic>
+        <p:nvPicPr>
+          <p:cNvPr id="12" name="Picture 11"/>
+          <p:cNvPicPr>
+            <a:picLocks noChangeAspect="1"/>
+          </p:cNvPicPr>
+          <p:nvPr/>
+        </p:nvPicPr>
+        <p:blipFill>
+          <a:blip r:embed="rId5"/>
+          <a:stretch>
+            <a:fillRect/>
+          </a:stretch>
+        </p:blipFill>
+        <p:spPr>
+          <a:xfrm>
+            <a:off x="6619873" y="1484408"/>
+            <a:ext cx="1771897" cy="1810003"/>
+          </a:xfrm>
+          <a:prstGeom prst="rect">
+            <a:avLst/>
+          </a:prstGeom>
+        </p:spPr>
+      </p:pic>
+      <p:sp>
+        <p:nvSpPr>
+          <p:cNvPr id="118" name="Google Shape;118;p16"/>
+          <p:cNvSpPr txBox="1"/>
+          <p:nvPr/>
+        </p:nvSpPr>
+        <p:spPr>
+          <a:xfrm>
+            <a:off x="571500" y="381000"/>
+            <a:ext cx="8001000" cy="952500"/>
+          </a:xfrm>
+          <a:prstGeom prst="rect">
+            <a:avLst/>
+          </a:prstGeom>
+          <a:solidFill>
+            <a:srgbClr val="000000">
+              <a:alpha val="0"/>
+            </a:srgbClr>
+          </a:solidFill>
+          <a:ln>
+            <a:noFill/>
+          </a:ln>
+        </p:spPr>
+        <p:txBody>
+          <a:bodyPr spcFirstLastPara="1" wrap="square" lIns="0" tIns="0" rIns="0" bIns="0" anchor="t" anchorCtr="0">
+            <a:noAutofit/>
+          </a:bodyPr>
+          <a:lstStyle/>
+          <a:p>
+            <a:pPr marL="0" lvl="0" indent="0" algn="l" rtl="0">
+              <a:spcBef>
+                <a:spcPts val="600"/>
+              </a:spcBef>
+              <a:spcAft>
+                <a:spcPts val="600"/>
+              </a:spcAft>
+              <a:buNone/>
+            </a:pPr>
+            <a:r>
+              <a:rPr lang="en-US" sz="1800" b="1" i="0" u="none" strike="noStrike" dirty="0">
+                <a:solidFill>
+                  <a:srgbClr val="FF5733"/>
+                </a:solidFill>
+                <a:latin typeface="Poppins" panose="00000800000000000000"/>
+                <a:ea typeface="Poppins" panose="00000800000000000000"/>
+                <a:cs typeface="Poppins" panose="00000800000000000000"/>
+                <a:sym typeface="Poppins" panose="00000800000000000000"/>
+              </a:rPr>
+              <a:t>LET’S GET STARTED</a:t>
+            </a:r>
+          </a:p>
+          <a:p>
+            <a:pPr marL="0" lvl="0" indent="0" algn="l" rtl="0">
+              <a:spcBef>
+                <a:spcPts val="600"/>
+              </a:spcBef>
+              <a:spcAft>
+                <a:spcPts val="600"/>
+              </a:spcAft>
+              <a:buNone/>
+            </a:pPr>
+            <a:r>
+              <a:rPr lang="en-US" altLang="en-GB" sz="2700" b="0" i="0" u="none" strike="noStrike" dirty="0">
+                <a:solidFill>
+                  <a:srgbClr val="0B132B"/>
+                </a:solidFill>
+                <a:latin typeface="Poppins SemiBold"/>
+                <a:ea typeface="Poppins SemiBold"/>
+                <a:cs typeface="Poppins SemiBold"/>
+                <a:sym typeface="Poppins SemiBold"/>
+              </a:rPr>
+              <a:t>Quick Question</a:t>
+            </a:r>
+          </a:p>
+        </p:txBody>
+      </p:sp>
+      <p:cxnSp>
+        <p:nvCxnSpPr>
+          <p:cNvPr id="93" name="Google Shape;93;p15"/>
+          <p:cNvCxnSpPr/>
+          <p:nvPr/>
+        </p:nvCxnSpPr>
+        <p:spPr>
+          <a:xfrm>
+            <a:off x="381000" y="1333500"/>
+            <a:ext cx="8382000" cy="0"/>
+          </a:xfrm>
+          <a:prstGeom prst="straightConnector1">
+            <a:avLst/>
+          </a:prstGeom>
+          <a:solidFill>
+            <a:srgbClr val="FFFFFF"/>
+          </a:solidFill>
+          <a:ln w="38100" cap="flat" cmpd="sng">
+            <a:solidFill>
+              <a:srgbClr val="111827"/>
+            </a:solidFill>
+            <a:prstDash val="solid"/>
+            <a:round/>
+            <a:headEnd type="none" w="sm" len="sm"/>
+            <a:tailEnd type="none" w="sm" len="sm"/>
+          </a:ln>
+        </p:spPr>
+      </p:cxnSp>
+      <p:pic>
+        <p:nvPicPr>
+          <p:cNvPr id="3" name="Picture 2"/>
+          <p:cNvPicPr>
+            <a:picLocks noChangeAspect="1"/>
+          </p:cNvPicPr>
+          <p:nvPr/>
+        </p:nvPicPr>
+        <p:blipFill>
+          <a:blip r:embed="rId6"/>
+          <a:stretch>
+            <a:fillRect/>
+          </a:stretch>
+        </p:blipFill>
+        <p:spPr>
+          <a:xfrm>
+            <a:off x="1877695" y="3637280"/>
+            <a:ext cx="4742180" cy="1042035"/>
+          </a:xfrm>
+          <a:prstGeom prst="rect">
+            <a:avLst/>
+          </a:prstGeom>
+        </p:spPr>
+      </p:pic>
+      <p:pic>
+        <p:nvPicPr>
+          <p:cNvPr id="5" name="Picture 4"/>
+          <p:cNvPicPr>
+            <a:picLocks noChangeAspect="1"/>
+          </p:cNvPicPr>
+          <p:nvPr/>
+        </p:nvPicPr>
+        <p:blipFill>
+          <a:blip r:embed="rId7"/>
+          <a:stretch>
+            <a:fillRect/>
+          </a:stretch>
+        </p:blipFill>
+        <p:spPr>
+          <a:xfrm>
+            <a:off x="4677410" y="1551305"/>
+            <a:ext cx="1714500" cy="1714500"/>
+          </a:xfrm>
+          <a:prstGeom prst="rect">
+            <a:avLst/>
+          </a:prstGeom>
+        </p:spPr>
+      </p:pic>
+    </p:spTree>
+  </p:cSld>
+  <p:clrMapOvr>
+    <a:masterClrMapping/>
+  </p:clrMapOvr>
+  <p:timing>
+    <p:tnLst>
+      <p:par>
+        <p:cTn id="1" dur="indefinite" restart="never" nodeType="tmRoot">
+          <p:childTnLst>
+            <p:seq concurrent="1" nextAc="seek">
+              <p:cTn id="2" dur="indefinite" nodeType="mainSeq">
+                <p:childTnLst>
+                  <p:par>
+                    <p:cTn id="3" fill="hold">
+                      <p:stCondLst>
+                        <p:cond delay="indefinite"/>
+                      </p:stCondLst>
+                      <p:childTnLst>
+                        <p:par>
+                          <p:cTn id="4" fill="hold">
+                            <p:stCondLst>
+                              <p:cond delay="0"/>
+                            </p:stCondLst>
+                            <p:childTnLst>
+                              <p:par>
+                                <p:cTn id="5" presetID="22" presetClass="entr" presetSubtype="4" fill="hold" nodeType="clickEffect">
+                                  <p:stCondLst>
+                                    <p:cond delay="0"/>
+                                  </p:stCondLst>
+                                  <p:childTnLst>
+                                    <p:set>
+                                      <p:cBhvr>
+                                        <p:cTn id="6" dur="1" fill="hold">
+                                          <p:stCondLst>
+                                            <p:cond delay="0"/>
+                                          </p:stCondLst>
+                                        </p:cTn>
+                                        <p:tgtEl>
+                                          <p:spTgt spid="6"/>
+                                        </p:tgtEl>
+                                        <p:attrNameLst>
+                                          <p:attrName>style.visibility</p:attrName>
+                                        </p:attrNameLst>
+                                      </p:cBhvr>
+                                      <p:to>
+                                        <p:strVal val="visible"/>
+                                      </p:to>
+                                    </p:set>
+                                    <p:animEffect transition="in" filter="wipe(down)">
+                                      <p:cBhvr>
+                                        <p:cTn id="7" dur="500"/>
+                                        <p:tgtEl>
+                                          <p:spTgt spid="6"/>
+                                        </p:tgtEl>
+                                      </p:cBhvr>
+                                    </p:animEffect>
+                                  </p:childTnLst>
+                                </p:cTn>
+                              </p:par>
+                            </p:childTnLst>
+                          </p:cTn>
+                        </p:par>
+                      </p:childTnLst>
+                    </p:cTn>
+                  </p:par>
+                  <p:par>
+                    <p:cTn id="8" fill="hold">
+                      <p:stCondLst>
+                        <p:cond delay="indefinite"/>
+                      </p:stCondLst>
+                      <p:childTnLst>
+                        <p:par>
+                          <p:cTn id="9" fill="hold">
+                            <p:stCondLst>
+                              <p:cond delay="0"/>
+                            </p:stCondLst>
+                            <p:childTnLst>
+                              <p:par>
+                                <p:cTn id="10" presetID="22" presetClass="entr" presetSubtype="4" fill="hold" nodeType="clickEffect">
+                                  <p:stCondLst>
+                                    <p:cond delay="0"/>
+                                  </p:stCondLst>
+                                  <p:childTnLst>
+                                    <p:set>
+                                      <p:cBhvr>
+                                        <p:cTn id="11" dur="1" fill="hold">
+                                          <p:stCondLst>
+                                            <p:cond delay="0"/>
+                                          </p:stCondLst>
+                                        </p:cTn>
+                                        <p:tgtEl>
+                                          <p:spTgt spid="8"/>
+                                        </p:tgtEl>
+                                        <p:attrNameLst>
+                                          <p:attrName>style.visibility</p:attrName>
+                                        </p:attrNameLst>
+                                      </p:cBhvr>
+                                      <p:to>
+                                        <p:strVal val="visible"/>
+                                      </p:to>
+                                    </p:set>
+                                    <p:animEffect transition="in" filter="wipe(down)">
+                                      <p:cBhvr>
+                                        <p:cTn id="12" dur="500"/>
+                                        <p:tgtEl>
+                                          <p:spTgt spid="8"/>
+                                        </p:tgtEl>
+                                      </p:cBhvr>
+                                    </p:animEffect>
+                                  </p:childTnLst>
+                                </p:cTn>
+                              </p:par>
+                            </p:childTnLst>
+                          </p:cTn>
+                        </p:par>
+                      </p:childTnLst>
+                    </p:cTn>
+                  </p:par>
+                  <p:par>
+                    <p:cTn id="13" fill="hold">
+                      <p:stCondLst>
+                        <p:cond delay="indefinite"/>
+                      </p:stCondLst>
+                      <p:childTnLst>
+                        <p:par>
+                          <p:cTn id="14" fill="hold">
+                            <p:stCondLst>
+                              <p:cond delay="0"/>
+                            </p:stCondLst>
+                            <p:childTnLst>
+                              <p:par>
+                                <p:cTn id="15" presetID="22" presetClass="entr" presetSubtype="4" fill="hold" nodeType="clickEffect">
+                                  <p:stCondLst>
+                                    <p:cond delay="0"/>
+                                  </p:stCondLst>
+                                  <p:childTnLst>
+                                    <p:set>
+                                      <p:cBhvr>
+                                        <p:cTn id="16" dur="1" fill="hold">
+                                          <p:stCondLst>
+                                            <p:cond delay="0"/>
+                                          </p:stCondLst>
+                                        </p:cTn>
+                                        <p:tgtEl>
+                                          <p:spTgt spid="5"/>
+                                        </p:tgtEl>
+                                        <p:attrNameLst>
+                                          <p:attrName>style.visibility</p:attrName>
+                                        </p:attrNameLst>
+                                      </p:cBhvr>
+                                      <p:to>
+                                        <p:strVal val="visible"/>
+                                      </p:to>
+                                    </p:set>
+                                    <p:animEffect transition="in" filter="wipe(down)">
+                                      <p:cBhvr>
+                                        <p:cTn id="17" dur="500"/>
+                                        <p:tgtEl>
+                                          <p:spTgt spid="5"/>
+                                        </p:tgtEl>
+                                      </p:cBhvr>
+                                    </p:animEffect>
+                                  </p:childTnLst>
+                                </p:cTn>
+                              </p:par>
+                            </p:childTnLst>
+                          </p:cTn>
+                        </p:par>
+                      </p:childTnLst>
+                    </p:cTn>
+                  </p:par>
+                  <p:par>
+                    <p:cTn id="18" fill="hold">
+                      <p:stCondLst>
+                        <p:cond delay="indefinite"/>
+                      </p:stCondLst>
+                      <p:childTnLst>
+                        <p:par>
+                          <p:cTn id="19" fill="hold">
+                            <p:stCondLst>
+                              <p:cond delay="0"/>
+                            </p:stCondLst>
+                            <p:childTnLst>
+                              <p:par>
+                                <p:cTn id="20" presetID="22" presetClass="entr" presetSubtype="4" fill="hold" nodeType="clickEffect">
+                                  <p:stCondLst>
+                                    <p:cond delay="0"/>
+                                  </p:stCondLst>
+                                  <p:childTnLst>
+                                    <p:set>
+                                      <p:cBhvr>
+                                        <p:cTn id="21" dur="1" fill="hold">
+                                          <p:stCondLst>
+                                            <p:cond delay="0"/>
+                                          </p:stCondLst>
+                                        </p:cTn>
+                                        <p:tgtEl>
+                                          <p:spTgt spid="12"/>
+                                        </p:tgtEl>
+                                        <p:attrNameLst>
+                                          <p:attrName>style.visibility</p:attrName>
+                                        </p:attrNameLst>
+                                      </p:cBhvr>
+                                      <p:to>
+                                        <p:strVal val="visible"/>
+                                      </p:to>
+                                    </p:set>
+                                    <p:animEffect transition="in" filter="wipe(down)">
+                                      <p:cBhvr>
+                                        <p:cTn id="22" dur="500"/>
+                                        <p:tgtEl>
+                                          <p:spTgt spid="12"/>
+                                        </p:tgtEl>
+                                      </p:cBhvr>
+                                    </p:animEffect>
+                                  </p:childTnLst>
+                                </p:cTn>
+                              </p:par>
+                            </p:childTnLst>
+                          </p:cTn>
+                        </p:par>
+                      </p:childTnLst>
+                    </p:cTn>
+                  </p:par>
+                  <p:par>
+                    <p:cTn id="23" fill="hold">
+                      <p:stCondLst>
+                        <p:cond delay="indefinite"/>
+                      </p:stCondLst>
+                      <p:childTnLst>
+                        <p:par>
+                          <p:cTn id="24" fill="hold">
+                            <p:stCondLst>
+                              <p:cond delay="0"/>
+                            </p:stCondLst>
+                            <p:childTnLst>
+                              <p:par>
+                                <p:cTn id="25" presetID="20" presetClass="entr" presetSubtype="0" fill="hold" nodeType="clickEffect">
+                                  <p:stCondLst>
+                                    <p:cond delay="0"/>
+                                  </p:stCondLst>
+                                  <p:childTnLst>
+                                    <p:set>
+                                      <p:cBhvr>
+                                        <p:cTn id="26" dur="1" fill="hold">
+                                          <p:stCondLst>
+                                            <p:cond delay="0"/>
+                                          </p:stCondLst>
+                                        </p:cTn>
+                                        <p:tgtEl>
+                                          <p:spTgt spid="3"/>
+                                        </p:tgtEl>
+                                        <p:attrNameLst>
+                                          <p:attrName>style.visibility</p:attrName>
+                                        </p:attrNameLst>
+                                      </p:cBhvr>
+                                      <p:to>
+                                        <p:strVal val="visible"/>
+                                      </p:to>
+                                    </p:set>
+                                    <p:animEffect transition="in" filter="wedge">
+                                      <p:cBhvr>
+                                        <p:cTn id="27" dur="2000"/>
+                                        <p:tgtEl>
+                                          <p:spTgt spid="3"/>
+                                        </p:tgtEl>
+                                      </p:cBhvr>
+                                    </p:animEffect>
+                                  </p:childTnLst>
+                                </p:cTn>
+                              </p:par>
+                            </p:childTnLst>
+                          </p:cTn>
+                        </p:par>
+                      </p:childTnLst>
+                    </p:cTn>
+                  </p:par>
+                </p:childTnLst>
+              </p:cTn>
+              <p:prevCondLst>
+                <p:cond evt="onPrev" delay="0">
+                  <p:tgtEl>
+                    <p:sldTgt/>
+                  </p:tgtEl>
+                </p:cond>
+              </p:prevCondLst>
+              <p:nextCondLst>
+                <p:cond evt="onNext" delay="0">
+                  <p:tgtEl>
+                    <p:sldTgt/>
+                  </p:tgtEl>
+                </p:cond>
+              </p:nextCondLst>
+            </p:seq>
+          </p:childTnLst>
+        </p:cTn>
+      </p:par>
+    </p:tnLst>
+  </p:timing>
+</p:sld>
+</file>
+
+<file path=ppt/slides/slide30.xml><?xml version="1.0" encoding="utf-8"?>
+<p:sld xmlns:a="http://schemas.openxmlformats.org/drawingml/2006/main" xmlns:r="http://schemas.openxmlformats.org/officeDocument/2006/relationships" xmlns:p="http://schemas.openxmlformats.org/presentationml/2006/main">
+  <p:cSld>
+    <p:spTree>
+      <p:nvGrpSpPr>
+        <p:cNvPr id="1" name="Shape 282">
+          <a:extLst>
+            <a:ext uri="{FF2B5EF4-FFF2-40B4-BE49-F238E27FC236}">
+              <a16:creationId xmlns:a16="http://schemas.microsoft.com/office/drawing/2014/main" id="{0372935D-9E15-08B0-73DC-90D5DAC6209B}"/>
+            </a:ext>
+          </a:extLst>
+        </p:cNvPr>
+        <p:cNvGrpSpPr/>
+        <p:nvPr/>
+      </p:nvGrpSpPr>
+      <p:grpSpPr>
+        <a:xfrm>
+          <a:off x="0" y="0"/>
+          <a:ext cx="0" cy="0"/>
+          <a:chOff x="0" y="0"/>
+          <a:chExt cx="0" cy="0"/>
+        </a:xfrm>
+      </p:grpSpPr>
+      <p:sp>
+        <p:nvSpPr>
+          <p:cNvPr id="283" name="Google Shape;283;p22">
+            <a:extLst>
+              <a:ext uri="{FF2B5EF4-FFF2-40B4-BE49-F238E27FC236}">
+                <a16:creationId xmlns:a16="http://schemas.microsoft.com/office/drawing/2014/main" id="{DE003C16-EEE2-B5BA-682F-F2B1B159B736}"/>
+              </a:ext>
+            </a:extLst>
+          </p:cNvPr>
+          <p:cNvSpPr/>
+          <p:nvPr/>
+        </p:nvSpPr>
+        <p:spPr>
+          <a:xfrm>
+            <a:off x="0" y="0"/>
+            <a:ext cx="9144000" cy="5143500"/>
+          </a:xfrm>
+          <a:prstGeom prst="rect">
+            <a:avLst/>
+          </a:prstGeom>
+          <a:solidFill>
+            <a:srgbClr val="F8F9FA"/>
+          </a:solidFill>
+          <a:ln>
+            <a:noFill/>
+          </a:ln>
+        </p:spPr>
+        <p:txBody>
+          <a:bodyPr spcFirstLastPara="1" wrap="square" lIns="0" tIns="0" rIns="0" bIns="0" anchor="ctr" anchorCtr="0">
+            <a:noAutofit/>
+          </a:bodyPr>
+          <a:lstStyle/>
+          <a:p>
+            <a:pPr marL="0" lvl="0" indent="0" algn="l" rtl="0">
+              <a:spcBef>
+                <a:spcPts val="0"/>
+              </a:spcBef>
+              <a:spcAft>
+                <a:spcPts val="0"/>
+              </a:spcAft>
+              <a:buNone/>
+            </a:pPr>
+            <a:endParaRPr/>
+          </a:p>
+        </p:txBody>
+      </p:sp>
+      <p:pic>
+        <p:nvPicPr>
+          <p:cNvPr id="80" name="Google Shape;80;p15">
+            <a:extLst>
+              <a:ext uri="{FF2B5EF4-FFF2-40B4-BE49-F238E27FC236}">
+                <a16:creationId xmlns:a16="http://schemas.microsoft.com/office/drawing/2014/main" id="{94ED8463-E37D-E3F5-A0BC-4C15287511BB}"/>
+              </a:ext>
+            </a:extLst>
+          </p:cNvPr>
+          <p:cNvPicPr preferRelativeResize="0"/>
+          <p:nvPr/>
+        </p:nvPicPr>
+        <p:blipFill rotWithShape="1">
+          <a:blip r:embed="rId3"/>
+          <a:srcRect/>
+          <a:stretch>
+            <a:fillRect/>
+          </a:stretch>
+        </p:blipFill>
+        <p:spPr>
+          <a:xfrm>
+            <a:off x="5080" y="5080"/>
+            <a:ext cx="9138920" cy="5139055"/>
+          </a:xfrm>
+          <a:prstGeom prst="rect">
+            <a:avLst/>
+          </a:prstGeom>
+          <a:noFill/>
+          <a:ln>
+            <a:noFill/>
+          </a:ln>
+        </p:spPr>
+      </p:pic>
+      <p:sp>
+        <p:nvSpPr>
+          <p:cNvPr id="284" name="Google Shape;284;p22">
+            <a:extLst>
+              <a:ext uri="{FF2B5EF4-FFF2-40B4-BE49-F238E27FC236}">
+                <a16:creationId xmlns:a16="http://schemas.microsoft.com/office/drawing/2014/main" id="{9F3D80D9-74A1-D464-4E93-8ACF088E491A}"/>
+              </a:ext>
+            </a:extLst>
+          </p:cNvPr>
+          <p:cNvSpPr/>
+          <p:nvPr/>
+        </p:nvSpPr>
+        <p:spPr>
+          <a:xfrm>
+            <a:off x="0" y="0"/>
+            <a:ext cx="9144000" cy="76200"/>
+          </a:xfrm>
+          <a:prstGeom prst="rect">
+            <a:avLst/>
+          </a:prstGeom>
+          <a:solidFill>
+            <a:srgbClr val="2D68FE"/>
+          </a:solidFill>
+          <a:ln>
+            <a:noFill/>
+          </a:ln>
+        </p:spPr>
+        <p:txBody>
+          <a:bodyPr spcFirstLastPara="1" wrap="square" lIns="0" tIns="0" rIns="0" bIns="0" anchor="ctr" anchorCtr="0">
+            <a:noAutofit/>
+          </a:bodyPr>
+          <a:lstStyle/>
+          <a:p>
+            <a:pPr marL="0" lvl="0" indent="0" algn="l" rtl="0">
+              <a:spcBef>
+                <a:spcPts val="0"/>
+              </a:spcBef>
+              <a:spcAft>
+                <a:spcPts val="0"/>
+              </a:spcAft>
+              <a:buNone/>
+            </a:pPr>
+            <a:endParaRPr/>
+          </a:p>
+        </p:txBody>
+      </p:sp>
+      <p:pic>
+        <p:nvPicPr>
+          <p:cNvPr id="286" name="Google Shape;286;p22">
+            <a:extLst>
+              <a:ext uri="{FF2B5EF4-FFF2-40B4-BE49-F238E27FC236}">
+                <a16:creationId xmlns:a16="http://schemas.microsoft.com/office/drawing/2014/main" id="{C776A9E6-A31F-EAD2-C571-5F98CA58585A}"/>
+              </a:ext>
+            </a:extLst>
+          </p:cNvPr>
+          <p:cNvPicPr preferRelativeResize="0"/>
+          <p:nvPr/>
+        </p:nvPicPr>
+        <p:blipFill rotWithShape="1">
+          <a:blip r:embed="rId4"/>
+          <a:srcRect/>
+          <a:stretch>
+            <a:fillRect/>
+          </a:stretch>
+        </p:blipFill>
+        <p:spPr>
+          <a:xfrm>
+            <a:off x="6848475" y="847725"/>
+            <a:ext cx="2276400" cy="3448200"/>
+          </a:xfrm>
+          <a:prstGeom prst="rect">
+            <a:avLst/>
+          </a:prstGeom>
+          <a:noFill/>
+          <a:ln>
+            <a:noFill/>
+          </a:ln>
+        </p:spPr>
+      </p:pic>
+      <p:sp>
+        <p:nvSpPr>
+          <p:cNvPr id="288" name="Google Shape;288;p22">
+            <a:extLst>
+              <a:ext uri="{FF2B5EF4-FFF2-40B4-BE49-F238E27FC236}">
+                <a16:creationId xmlns:a16="http://schemas.microsoft.com/office/drawing/2014/main" id="{02329036-6311-FF33-7C91-6F92FDCCCFFC}"/>
+              </a:ext>
+            </a:extLst>
+          </p:cNvPr>
+          <p:cNvSpPr txBox="1"/>
+          <p:nvPr/>
+        </p:nvSpPr>
+        <p:spPr>
+          <a:xfrm>
+            <a:off x="571500" y="381000"/>
+            <a:ext cx="8001000" cy="1047900"/>
+          </a:xfrm>
+          <a:prstGeom prst="rect">
+            <a:avLst/>
+          </a:prstGeom>
+          <a:solidFill>
+            <a:srgbClr val="000000">
+              <a:alpha val="0"/>
+            </a:srgbClr>
+          </a:solidFill>
+          <a:ln>
+            <a:noFill/>
+          </a:ln>
+        </p:spPr>
+        <p:txBody>
+          <a:bodyPr spcFirstLastPara="1" wrap="square" lIns="0" tIns="0" rIns="0" bIns="0" anchor="t" anchorCtr="0">
+            <a:noAutofit/>
+          </a:bodyPr>
+          <a:lstStyle/>
+          <a:p>
+            <a:pPr marL="0" lvl="0" indent="0" algn="l" rtl="0">
+              <a:spcBef>
+                <a:spcPts val="0"/>
+              </a:spcBef>
+              <a:spcAft>
+                <a:spcPts val="0"/>
+              </a:spcAft>
+              <a:buNone/>
+            </a:pPr>
+            <a:r>
+              <a:rPr lang="en-GB" sz="1800" b="1" i="0" u="none" strike="noStrike" dirty="0">
+                <a:solidFill>
+                  <a:srgbClr val="FF5733"/>
+                </a:solidFill>
+                <a:latin typeface="Poppins" panose="00000800000000000000"/>
+                <a:ea typeface="Poppins" panose="00000800000000000000"/>
+                <a:cs typeface="Poppins" panose="00000800000000000000"/>
+                <a:sym typeface="Poppins" panose="00000800000000000000"/>
+              </a:rPr>
+              <a:t>RESUME STRATEGY</a:t>
+            </a:r>
+            <a:endParaRPr sz="1800" b="1" i="0" u="none" strike="noStrike" dirty="0">
+              <a:solidFill>
+                <a:srgbClr val="FF5733"/>
+              </a:solidFill>
+              <a:latin typeface="Poppins" panose="00000800000000000000"/>
+              <a:ea typeface="Poppins" panose="00000800000000000000"/>
+              <a:cs typeface="Poppins" panose="00000800000000000000"/>
+              <a:sym typeface="Poppins" panose="00000800000000000000"/>
+            </a:endParaRPr>
+          </a:p>
+          <a:p>
+            <a:pPr marL="0" lvl="0" indent="0" algn="l" rtl="0">
+              <a:spcBef>
+                <a:spcPts val="600"/>
+              </a:spcBef>
+              <a:spcAft>
+                <a:spcPts val="600"/>
+              </a:spcAft>
+              <a:buNone/>
+            </a:pPr>
+            <a:r>
+              <a:rPr lang="en-GB" sz="2700" b="0" i="0" u="none" strike="noStrike" dirty="0">
+                <a:solidFill>
+                  <a:srgbClr val="0B132B"/>
+                </a:solidFill>
+                <a:latin typeface="Poppins SemiBold"/>
+                <a:ea typeface="Poppins SemiBold"/>
+                <a:cs typeface="Poppins SemiBold"/>
+                <a:sym typeface="Poppins SemiBold"/>
+              </a:rPr>
+              <a:t>Showcasing Your Projects for Impact</a:t>
+            </a:r>
+            <a:endParaRPr sz="1800" b="1" i="0" u="none" strike="noStrike" dirty="0">
+              <a:solidFill>
+                <a:srgbClr val="FF5733"/>
+              </a:solidFill>
+              <a:latin typeface="Poppins" panose="00000800000000000000"/>
+              <a:ea typeface="Poppins" panose="00000800000000000000"/>
+              <a:cs typeface="Poppins" panose="00000800000000000000"/>
+              <a:sym typeface="Poppins" panose="00000800000000000000"/>
+            </a:endParaRPr>
+          </a:p>
+        </p:txBody>
+      </p:sp>
+      <p:cxnSp>
+        <p:nvCxnSpPr>
+          <p:cNvPr id="93" name="Google Shape;93;p15">
+            <a:extLst>
+              <a:ext uri="{FF2B5EF4-FFF2-40B4-BE49-F238E27FC236}">
+                <a16:creationId xmlns:a16="http://schemas.microsoft.com/office/drawing/2014/main" id="{E1FEDCE1-E815-21D9-B9AE-AB92C7F14270}"/>
+              </a:ext>
+            </a:extLst>
+          </p:cNvPr>
+          <p:cNvCxnSpPr/>
+          <p:nvPr/>
+        </p:nvCxnSpPr>
+        <p:spPr>
+          <a:xfrm>
+            <a:off x="311785" y="1333500"/>
+            <a:ext cx="8382000" cy="0"/>
+          </a:xfrm>
+          <a:prstGeom prst="straightConnector1">
+            <a:avLst/>
+          </a:prstGeom>
+          <a:solidFill>
+            <a:srgbClr val="FFFFFF"/>
+          </a:solidFill>
+          <a:ln w="38100" cap="flat" cmpd="sng">
+            <a:solidFill>
+              <a:srgbClr val="111827"/>
+            </a:solidFill>
+            <a:prstDash val="solid"/>
+            <a:round/>
+            <a:headEnd type="none" w="sm" len="sm"/>
+            <a:tailEnd type="none" w="sm" len="sm"/>
+          </a:ln>
+        </p:spPr>
+      </p:cxnSp>
+      <p:sp>
+        <p:nvSpPr>
+          <p:cNvPr id="7" name="TextBox 6">
+            <a:extLst>
+              <a:ext uri="{FF2B5EF4-FFF2-40B4-BE49-F238E27FC236}">
+                <a16:creationId xmlns:a16="http://schemas.microsoft.com/office/drawing/2014/main" id="{98D54481-BD27-FE40-DF4F-AC2169EF7008}"/>
+              </a:ext>
+            </a:extLst>
+          </p:cNvPr>
+          <p:cNvSpPr txBox="1"/>
+          <p:nvPr/>
+        </p:nvSpPr>
+        <p:spPr>
+          <a:xfrm>
+            <a:off x="371437" y="1560709"/>
+            <a:ext cx="8401125" cy="1384995"/>
+          </a:xfrm>
+          <a:prstGeom prst="rect">
+            <a:avLst/>
+          </a:prstGeom>
+          <a:noFill/>
+        </p:spPr>
+        <p:txBody>
+          <a:bodyPr wrap="square">
+            <a:spAutoFit/>
+          </a:bodyPr>
+          <a:lstStyle/>
+          <a:p>
+            <a:r>
+              <a:rPr lang="en-US" b="1" dirty="0"/>
+              <a:t>Student Performance Prediction System (AI/ML Project) – Typical Version</a:t>
+            </a:r>
+          </a:p>
+          <a:p>
+            <a:endParaRPr lang="en-US" b="1" dirty="0"/>
+          </a:p>
+          <a:p>
+            <a:r>
+              <a:rPr lang="en-US" dirty="0"/>
+              <a:t>Developed a ML project to predict student performance using Python, Pandas, NumPy and Scikit-learn. Collected and preprocessed the data, performed data analysis, implemented different machine learning algorithms and compared their accuracy. Used Random Forest to predict student performance and created graphs using Matplotlib.</a:t>
+            </a:r>
+          </a:p>
+        </p:txBody>
+      </p:sp>
+      <p:sp>
+        <p:nvSpPr>
+          <p:cNvPr id="8" name="TextBox 7">
+            <a:extLst>
+              <a:ext uri="{FF2B5EF4-FFF2-40B4-BE49-F238E27FC236}">
+                <a16:creationId xmlns:a16="http://schemas.microsoft.com/office/drawing/2014/main" id="{D34A8A30-4FCE-5020-B17A-64FAD9936E85}"/>
+              </a:ext>
+            </a:extLst>
+          </p:cNvPr>
+          <p:cNvSpPr txBox="1"/>
+          <p:nvPr/>
+        </p:nvSpPr>
+        <p:spPr>
+          <a:xfrm>
+            <a:off x="302222" y="3165233"/>
+            <a:ext cx="8401125" cy="1600438"/>
+          </a:xfrm>
+          <a:prstGeom prst="rect">
+            <a:avLst/>
+          </a:prstGeom>
+          <a:noFill/>
+        </p:spPr>
+        <p:txBody>
+          <a:bodyPr wrap="square">
+            <a:spAutoFit/>
+          </a:bodyPr>
+          <a:lstStyle/>
+          <a:p>
+            <a:r>
+              <a:rPr lang="en-US" b="1" dirty="0"/>
+              <a:t>Student Performance Prediction System(AI/ML Project) – Improved, Impact-Focused Version</a:t>
+            </a:r>
+          </a:p>
+          <a:p>
+            <a:endParaRPr lang="en-US" b="1" dirty="0"/>
+          </a:p>
+          <a:p>
+            <a:r>
+              <a:rPr lang="en-US" dirty="0"/>
+              <a:t>Developed a machine learning solution to identify students who may require additional academic support based on attendance, previous scores, study time and assignment completion. Processed </a:t>
+            </a:r>
+            <a:r>
+              <a:rPr lang="en-US" b="1" dirty="0"/>
+              <a:t>5,000+ student records</a:t>
+            </a:r>
+            <a:r>
+              <a:rPr lang="en-US" dirty="0"/>
+              <a:t>, performed data preprocessing &amp; feature selection, and implemented. Compared Logistic Regression, Decision Tree and Random Forest models using</a:t>
+            </a:r>
+            <a:r>
+              <a:rPr lang="en-US" b="1" dirty="0"/>
+              <a:t> Scikit-learn</a:t>
+            </a:r>
+            <a:r>
+              <a:rPr lang="en-US" dirty="0"/>
+              <a:t> and achieved prediction accuracy of </a:t>
+            </a:r>
+            <a:r>
+              <a:rPr lang="en-US" b="1" dirty="0"/>
+              <a:t>82% </a:t>
+            </a:r>
+            <a:r>
+              <a:rPr lang="en-US" dirty="0"/>
+              <a:t>using Random Forest model.</a:t>
+            </a:r>
+          </a:p>
+        </p:txBody>
+      </p:sp>
+    </p:spTree>
+    <p:extLst>
+      <p:ext uri="{BB962C8B-B14F-4D97-AF65-F5344CB8AC3E}">
+        <p14:creationId xmlns:p14="http://schemas.microsoft.com/office/powerpoint/2010/main" val="2909439857"/>
+      </p:ext>
+    </p:extLst>
+  </p:cSld>
+  <p:clrMapOvr>
+    <a:masterClrMapping/>
+  </p:clrMapOvr>
+  <p:timing>
+    <p:tnLst>
+      <p:par>
+        <p:cTn id="1" dur="indefinite" restart="never" nodeType="tmRoot">
+          <p:childTnLst>
+            <p:seq concurrent="1" nextAc="seek">
+              <p:cTn id="2" dur="indefinite" nodeType="mainSeq">
+                <p:childTnLst>
+                  <p:par>
+                    <p:cTn id="3" fill="hold">
+                      <p:stCondLst>
+                        <p:cond delay="indefinite"/>
+                      </p:stCondLst>
+                      <p:childTnLst>
+                        <p:par>
+                          <p:cTn id="4" fill="hold">
+                            <p:stCondLst>
+                              <p:cond delay="0"/>
+                            </p:stCondLst>
+                            <p:childTnLst>
+                              <p:par>
+                                <p:cTn id="5" presetID="1" presetClass="entr" presetSubtype="0" fill="hold" grpId="0" nodeType="clickEffect">
+                                  <p:stCondLst>
+                                    <p:cond delay="0"/>
+                                  </p:stCondLst>
+                                  <p:childTnLst>
+                                    <p:set>
+                                      <p:cBhvr>
+                                        <p:cTn id="6" dur="1" fill="hold">
+                                          <p:stCondLst>
+                                            <p:cond delay="0"/>
+                                          </p:stCondLst>
+                                        </p:cTn>
+                                        <p:tgtEl>
+                                          <p:spTgt spid="7"/>
+                                        </p:tgtEl>
+                                        <p:attrNameLst>
+                                          <p:attrName>style.visibility</p:attrName>
+                                        </p:attrNameLst>
+                                      </p:cBhvr>
+                                      <p:to>
+                                        <p:strVal val="visible"/>
+                                      </p:to>
+                                    </p:set>
+                                  </p:childTnLst>
+                                </p:cTn>
+                              </p:par>
+                            </p:childTnLst>
+                          </p:cTn>
+                        </p:par>
+                      </p:childTnLst>
+                    </p:cTn>
+                  </p:par>
+                  <p:par>
+                    <p:cTn id="7" fill="hold">
+                      <p:stCondLst>
+                        <p:cond delay="indefinite"/>
+                      </p:stCondLst>
+                      <p:childTnLst>
+                        <p:par>
+                          <p:cTn id="8" fill="hold">
+                            <p:stCondLst>
+                              <p:cond delay="0"/>
+                            </p:stCondLst>
+                            <p:childTnLst>
+                              <p:par>
+                                <p:cTn id="9" presetID="1" presetClass="entr" presetSubtype="0" fill="hold" grpId="0" nodeType="clickEffect">
+                                  <p:stCondLst>
+                                    <p:cond delay="0"/>
+                                  </p:stCondLst>
+                                  <p:childTnLst>
+                                    <p:set>
+                                      <p:cBhvr>
+                                        <p:cTn id="10" dur="1" fill="hold">
+                                          <p:stCondLst>
+                                            <p:cond delay="0"/>
+                                          </p:stCondLst>
+                                        </p:cTn>
+                                        <p:tgtEl>
+                                          <p:spTgt spid="8"/>
+                                        </p:tgtEl>
+                                        <p:attrNameLst>
+                                          <p:attrName>style.visibility</p:attrName>
+                                        </p:attrNameLst>
+                                      </p:cBhvr>
+                                      <p:to>
+                                        <p:strVal val="visible"/>
+                                      </p:to>
+                                    </p:set>
+                                  </p:childTnLst>
+                                </p:cTn>
+                              </p:par>
+                            </p:childTnLst>
+                          </p:cTn>
+                        </p:par>
+                      </p:childTnLst>
+                    </p:cTn>
+                  </p:par>
+                </p:childTnLst>
+              </p:cTn>
+              <p:prevCondLst>
+                <p:cond evt="onPrev" delay="0">
+                  <p:tgtEl>
+                    <p:sldTgt/>
+                  </p:tgtEl>
+                </p:cond>
+              </p:prevCondLst>
+              <p:nextCondLst>
+                <p:cond evt="onNext" delay="0">
+                  <p:tgtEl>
+                    <p:sldTgt/>
+                  </p:tgtEl>
+                </p:cond>
+              </p:nextCondLst>
+            </p:seq>
+          </p:childTnLst>
+        </p:cTn>
+      </p:par>
+    </p:tnLst>
+    <p:bldLst>
+      <p:bldP spid="7" grpId="0"/>
+      <p:bldP spid="8" grpId="0"/>
+    </p:bldLst>
+  </p:timing>
+</p:sld>
+</file>
+
+<file path=ppt/slides/slide31.xml><?xml version="1.0" encoding="utf-8"?>
 <p:sld xmlns:a="http://schemas.openxmlformats.org/drawingml/2006/main" xmlns:r="http://schemas.openxmlformats.org/officeDocument/2006/relationships" xmlns:p="http://schemas.openxmlformats.org/presentationml/2006/main" show="0">
   <p:cSld>
     <p:spTree>
@@ -34277,733 +36413,7 @@
 </p:sld>
 </file>
 
-<file path=ppt/slides/slide3.xml><?xml version="1.0" encoding="utf-8"?>
-<p:sld xmlns:a="http://schemas.openxmlformats.org/drawingml/2006/main" xmlns:r="http://schemas.openxmlformats.org/officeDocument/2006/relationships" xmlns:p="http://schemas.openxmlformats.org/presentationml/2006/main">
-  <p:cSld>
-    <p:spTree>
-      <p:nvGrpSpPr>
-        <p:cNvPr id="1" name=""/>
-        <p:cNvGrpSpPr/>
-        <p:nvPr/>
-      </p:nvGrpSpPr>
-      <p:grpSpPr>
-        <a:xfrm>
-          <a:off x="0" y="0"/>
-          <a:ext cx="0" cy="0"/>
-          <a:chOff x="0" y="0"/>
-          <a:chExt cx="0" cy="0"/>
-        </a:xfrm>
-      </p:grpSpPr>
-      <p:grpSp>
-        <p:nvGrpSpPr>
-          <p:cNvPr id="78" name="Google Shape;78;p15"/>
-          <p:cNvGrpSpPr/>
-          <p:nvPr/>
-        </p:nvGrpSpPr>
-        <p:grpSpPr>
-          <a:xfrm>
-            <a:off x="0" y="0"/>
-            <a:ext cx="9144150" cy="5143650"/>
-            <a:chOff x="0" y="0"/>
-            <a:chExt cx="9144150" cy="5143650"/>
-          </a:xfrm>
-        </p:grpSpPr>
-        <p:sp>
-          <p:nvSpPr>
-            <p:cNvPr id="79" name="Google Shape;79;p15"/>
-            <p:cNvSpPr/>
-            <p:nvPr/>
-          </p:nvSpPr>
-          <p:spPr>
-            <a:xfrm>
-              <a:off x="0" y="0"/>
-              <a:ext cx="9144000" cy="5143500"/>
-            </a:xfrm>
-            <a:prstGeom prst="rect">
-              <a:avLst/>
-            </a:prstGeom>
-            <a:solidFill>
-              <a:srgbClr val="F8F9FA"/>
-            </a:solidFill>
-            <a:ln>
-              <a:noFill/>
-            </a:ln>
-          </p:spPr>
-          <p:txBody>
-            <a:bodyPr spcFirstLastPara="1" wrap="square" lIns="0" tIns="0" rIns="0" bIns="0" anchor="ctr" anchorCtr="0">
-              <a:noAutofit/>
-            </a:bodyPr>
-            <a:lstStyle/>
-            <a:p>
-              <a:pPr marL="0" lvl="0" indent="0" algn="l" rtl="0">
-                <a:spcBef>
-                  <a:spcPts val="0"/>
-                </a:spcBef>
-                <a:spcAft>
-                  <a:spcPts val="0"/>
-                </a:spcAft>
-                <a:buNone/>
-              </a:pPr>
-              <a:endParaRPr/>
-            </a:p>
-          </p:txBody>
-        </p:sp>
-        <p:pic>
-          <p:nvPicPr>
-            <p:cNvPr id="80" name="Google Shape;80;p15"/>
-            <p:cNvPicPr preferRelativeResize="0"/>
-            <p:nvPr/>
-          </p:nvPicPr>
-          <p:blipFill rotWithShape="1">
-            <a:blip r:embed="rId2"/>
-            <a:srcRect/>
-            <a:stretch>
-              <a:fillRect/>
-            </a:stretch>
-          </p:blipFill>
-          <p:spPr>
-            <a:xfrm>
-              <a:off x="4763" y="4763"/>
-              <a:ext cx="8982000" cy="4981500"/>
-            </a:xfrm>
-            <a:prstGeom prst="rect">
-              <a:avLst/>
-            </a:prstGeom>
-            <a:noFill/>
-            <a:ln>
-              <a:noFill/>
-            </a:ln>
-          </p:spPr>
-        </p:pic>
-        <p:sp>
-          <p:nvSpPr>
-            <p:cNvPr id="81" name="Google Shape;81;p15"/>
-            <p:cNvSpPr/>
-            <p:nvPr/>
-          </p:nvSpPr>
-          <p:spPr>
-            <a:xfrm>
-              <a:off x="0" y="0"/>
-              <a:ext cx="9144000" cy="76200"/>
-            </a:xfrm>
-            <a:prstGeom prst="rect">
-              <a:avLst/>
-            </a:prstGeom>
-            <a:solidFill>
-              <a:srgbClr val="2D68FE"/>
-            </a:solidFill>
-            <a:ln>
-              <a:noFill/>
-            </a:ln>
-          </p:spPr>
-          <p:txBody>
-            <a:bodyPr spcFirstLastPara="1" wrap="square" lIns="0" tIns="0" rIns="0" bIns="0" anchor="ctr" anchorCtr="0">
-              <a:noAutofit/>
-            </a:bodyPr>
-            <a:lstStyle/>
-            <a:p>
-              <a:pPr marL="0" lvl="0" indent="0" algn="l" rtl="0">
-                <a:spcBef>
-                  <a:spcPts val="0"/>
-                </a:spcBef>
-                <a:spcAft>
-                  <a:spcPts val="0"/>
-                </a:spcAft>
-                <a:buNone/>
-              </a:pPr>
-              <a:endParaRPr/>
-            </a:p>
-          </p:txBody>
-        </p:sp>
-        <p:sp>
-          <p:nvSpPr>
-            <p:cNvPr id="82" name="Google Shape;82;p15"/>
-            <p:cNvSpPr/>
-            <p:nvPr/>
-          </p:nvSpPr>
-          <p:spPr>
-            <a:xfrm>
-              <a:off x="8477250" y="4476750"/>
-              <a:ext cx="666900" cy="666900"/>
-            </a:xfrm>
-            <a:custGeom>
-              <a:avLst/>
-              <a:gdLst/>
-              <a:ahLst/>
-              <a:cxnLst/>
-              <a:rect l="l" t="t" r="r" b="b"/>
-              <a:pathLst>
-                <a:path w="120000" h="120000" extrusionOk="0">
-                  <a:moveTo>
-                    <a:pt x="120000" y="120000"/>
-                  </a:moveTo>
-                  <a:lnTo>
-                    <a:pt x="120000" y="0"/>
-                  </a:lnTo>
-                  <a:lnTo>
-                    <a:pt x="0" y="120000"/>
-                  </a:lnTo>
-                  <a:close/>
-                </a:path>
-              </a:pathLst>
-            </a:custGeom>
-            <a:solidFill>
-              <a:srgbClr val="FFC300">
-                <a:alpha val="69999"/>
-              </a:srgbClr>
-            </a:solidFill>
-            <a:ln>
-              <a:noFill/>
-            </a:ln>
-          </p:spPr>
-          <p:txBody>
-            <a:bodyPr spcFirstLastPara="1" wrap="square" lIns="0" tIns="0" rIns="0" bIns="0" anchor="ctr" anchorCtr="0">
-              <a:noAutofit/>
-            </a:bodyPr>
-            <a:lstStyle/>
-            <a:p>
-              <a:pPr marL="0" lvl="0" indent="0" algn="l" rtl="0">
-                <a:spcBef>
-                  <a:spcPts val="0"/>
-                </a:spcBef>
-                <a:spcAft>
-                  <a:spcPts val="0"/>
-                </a:spcAft>
-                <a:buNone/>
-              </a:pPr>
-              <a:endParaRPr/>
-            </a:p>
-          </p:txBody>
-        </p:sp>
-      </p:grpSp>
-      <p:pic>
-        <p:nvPicPr>
-          <p:cNvPr id="6" name="Picture 5"/>
-          <p:cNvPicPr>
-            <a:picLocks noChangeAspect="1"/>
-          </p:cNvPicPr>
-          <p:nvPr/>
-        </p:nvPicPr>
-        <p:blipFill>
-          <a:blip r:embed="rId3"/>
-          <a:stretch>
-            <a:fillRect/>
-          </a:stretch>
-        </p:blipFill>
-        <p:spPr>
-          <a:xfrm>
-            <a:off x="562531" y="1551094"/>
-            <a:ext cx="1781424" cy="1714739"/>
-          </a:xfrm>
-          <a:prstGeom prst="rect">
-            <a:avLst/>
-          </a:prstGeom>
-        </p:spPr>
-      </p:pic>
-      <p:pic>
-        <p:nvPicPr>
-          <p:cNvPr id="8" name="Picture 7"/>
-          <p:cNvPicPr>
-            <a:picLocks noChangeAspect="1"/>
-          </p:cNvPicPr>
-          <p:nvPr/>
-        </p:nvPicPr>
-        <p:blipFill>
-          <a:blip r:embed="rId4"/>
-          <a:stretch>
-            <a:fillRect/>
-          </a:stretch>
-        </p:blipFill>
-        <p:spPr>
-          <a:xfrm>
-            <a:off x="2629457" y="1512988"/>
-            <a:ext cx="1762371" cy="1752845"/>
-          </a:xfrm>
-          <a:prstGeom prst="rect">
-            <a:avLst/>
-          </a:prstGeom>
-        </p:spPr>
-      </p:pic>
-      <p:pic>
-        <p:nvPicPr>
-          <p:cNvPr id="12" name="Picture 11"/>
-          <p:cNvPicPr>
-            <a:picLocks noChangeAspect="1"/>
-          </p:cNvPicPr>
-          <p:nvPr/>
-        </p:nvPicPr>
-        <p:blipFill>
-          <a:blip r:embed="rId5"/>
-          <a:stretch>
-            <a:fillRect/>
-          </a:stretch>
-        </p:blipFill>
-        <p:spPr>
-          <a:xfrm>
-            <a:off x="6619873" y="1484408"/>
-            <a:ext cx="1771897" cy="1810003"/>
-          </a:xfrm>
-          <a:prstGeom prst="rect">
-            <a:avLst/>
-          </a:prstGeom>
-        </p:spPr>
-      </p:pic>
-      <p:sp>
-        <p:nvSpPr>
-          <p:cNvPr id="118" name="Google Shape;118;p16"/>
-          <p:cNvSpPr txBox="1"/>
-          <p:nvPr/>
-        </p:nvSpPr>
-        <p:spPr>
-          <a:xfrm>
-            <a:off x="571500" y="381000"/>
-            <a:ext cx="8001000" cy="952500"/>
-          </a:xfrm>
-          <a:prstGeom prst="rect">
-            <a:avLst/>
-          </a:prstGeom>
-          <a:solidFill>
-            <a:srgbClr val="000000">
-              <a:alpha val="0"/>
-            </a:srgbClr>
-          </a:solidFill>
-          <a:ln>
-            <a:noFill/>
-          </a:ln>
-        </p:spPr>
-        <p:txBody>
-          <a:bodyPr spcFirstLastPara="1" wrap="square" lIns="0" tIns="0" rIns="0" bIns="0" anchor="t" anchorCtr="0">
-            <a:noAutofit/>
-          </a:bodyPr>
-          <a:lstStyle/>
-          <a:p>
-            <a:pPr marL="0" lvl="0" indent="0" algn="l" rtl="0">
-              <a:spcBef>
-                <a:spcPts val="600"/>
-              </a:spcBef>
-              <a:spcAft>
-                <a:spcPts val="600"/>
-              </a:spcAft>
-              <a:buNone/>
-            </a:pPr>
-            <a:r>
-              <a:rPr lang="en-US" sz="1800" b="1" i="0" u="none" strike="noStrike" dirty="0">
-                <a:solidFill>
-                  <a:srgbClr val="FF5733"/>
-                </a:solidFill>
-                <a:latin typeface="Poppins" panose="00000800000000000000"/>
-                <a:ea typeface="Poppins" panose="00000800000000000000"/>
-                <a:cs typeface="Poppins" panose="00000800000000000000"/>
-                <a:sym typeface="Poppins" panose="00000800000000000000"/>
-              </a:rPr>
-              <a:t>LET’S GET STARTED</a:t>
-            </a:r>
-          </a:p>
-          <a:p>
-            <a:pPr marL="0" lvl="0" indent="0" algn="l" rtl="0">
-              <a:spcBef>
-                <a:spcPts val="600"/>
-              </a:spcBef>
-              <a:spcAft>
-                <a:spcPts val="600"/>
-              </a:spcAft>
-              <a:buNone/>
-            </a:pPr>
-            <a:r>
-              <a:rPr lang="en-US" altLang="en-GB" sz="2700" b="0" i="0" u="none" strike="noStrike" dirty="0">
-                <a:solidFill>
-                  <a:srgbClr val="0B132B"/>
-                </a:solidFill>
-                <a:latin typeface="Poppins SemiBold"/>
-                <a:ea typeface="Poppins SemiBold"/>
-                <a:cs typeface="Poppins SemiBold"/>
-                <a:sym typeface="Poppins SemiBold"/>
-              </a:rPr>
-              <a:t>Quick Question</a:t>
-            </a:r>
-          </a:p>
-        </p:txBody>
-      </p:sp>
-      <p:cxnSp>
-        <p:nvCxnSpPr>
-          <p:cNvPr id="93" name="Google Shape;93;p15"/>
-          <p:cNvCxnSpPr/>
-          <p:nvPr/>
-        </p:nvCxnSpPr>
-        <p:spPr>
-          <a:xfrm>
-            <a:off x="381000" y="1333500"/>
-            <a:ext cx="8382000" cy="0"/>
-          </a:xfrm>
-          <a:prstGeom prst="straightConnector1">
-            <a:avLst/>
-          </a:prstGeom>
-          <a:solidFill>
-            <a:srgbClr val="FFFFFF"/>
-          </a:solidFill>
-          <a:ln w="38100" cap="flat" cmpd="sng">
-            <a:solidFill>
-              <a:srgbClr val="111827"/>
-            </a:solidFill>
-            <a:prstDash val="solid"/>
-            <a:round/>
-            <a:headEnd type="none" w="sm" len="sm"/>
-            <a:tailEnd type="none" w="sm" len="sm"/>
-          </a:ln>
-        </p:spPr>
-      </p:cxnSp>
-      <p:pic>
-        <p:nvPicPr>
-          <p:cNvPr id="3" name="Picture 2"/>
-          <p:cNvPicPr>
-            <a:picLocks noChangeAspect="1"/>
-          </p:cNvPicPr>
-          <p:nvPr/>
-        </p:nvPicPr>
-        <p:blipFill>
-          <a:blip r:embed="rId6"/>
-          <a:stretch>
-            <a:fillRect/>
-          </a:stretch>
-        </p:blipFill>
-        <p:spPr>
-          <a:xfrm>
-            <a:off x="1877695" y="3637280"/>
-            <a:ext cx="4742180" cy="1042035"/>
-          </a:xfrm>
-          <a:prstGeom prst="rect">
-            <a:avLst/>
-          </a:prstGeom>
-        </p:spPr>
-      </p:pic>
-      <p:pic>
-        <p:nvPicPr>
-          <p:cNvPr id="5" name="Picture 4"/>
-          <p:cNvPicPr>
-            <a:picLocks noChangeAspect="1"/>
-          </p:cNvPicPr>
-          <p:nvPr/>
-        </p:nvPicPr>
-        <p:blipFill>
-          <a:blip r:embed="rId7"/>
-          <a:stretch>
-            <a:fillRect/>
-          </a:stretch>
-        </p:blipFill>
-        <p:spPr>
-          <a:xfrm>
-            <a:off x="4677410" y="1551305"/>
-            <a:ext cx="1714500" cy="1714500"/>
-          </a:xfrm>
-          <a:prstGeom prst="rect">
-            <a:avLst/>
-          </a:prstGeom>
-        </p:spPr>
-      </p:pic>
-    </p:spTree>
-  </p:cSld>
-  <p:clrMapOvr>
-    <a:masterClrMapping/>
-  </p:clrMapOvr>
-  <p:timing>
-    <p:tnLst>
-      <p:par>
-        <p:cTn id="1" dur="indefinite" restart="never" nodeType="tmRoot">
-          <p:childTnLst>
-            <p:seq concurrent="1" nextAc="seek">
-              <p:cTn id="2" dur="indefinite" nodeType="mainSeq">
-                <p:childTnLst>
-                  <p:par>
-                    <p:cTn id="3" fill="hold">
-                      <p:stCondLst>
-                        <p:cond delay="indefinite"/>
-                      </p:stCondLst>
-                      <p:childTnLst>
-                        <p:par>
-                          <p:cTn id="4" fill="hold">
-                            <p:stCondLst>
-                              <p:cond delay="0"/>
-                            </p:stCondLst>
-                            <p:childTnLst>
-                              <p:par>
-                                <p:cTn id="5" presetID="22" presetClass="entr" presetSubtype="4" fill="hold" nodeType="clickEffect">
-                                  <p:stCondLst>
-                                    <p:cond delay="0"/>
-                                  </p:stCondLst>
-                                  <p:childTnLst>
-                                    <p:set>
-                                      <p:cBhvr>
-                                        <p:cTn id="6" dur="1" fill="hold">
-                                          <p:stCondLst>
-                                            <p:cond delay="0"/>
-                                          </p:stCondLst>
-                                        </p:cTn>
-                                        <p:tgtEl>
-                                          <p:spTgt spid="6"/>
-                                        </p:tgtEl>
-                                        <p:attrNameLst>
-                                          <p:attrName>style.visibility</p:attrName>
-                                        </p:attrNameLst>
-                                      </p:cBhvr>
-                                      <p:to>
-                                        <p:strVal val="visible"/>
-                                      </p:to>
-                                    </p:set>
-                                    <p:animEffect transition="in" filter="wipe(down)">
-                                      <p:cBhvr>
-                                        <p:cTn id="7" dur="500"/>
-                                        <p:tgtEl>
-                                          <p:spTgt spid="6"/>
-                                        </p:tgtEl>
-                                      </p:cBhvr>
-                                    </p:animEffect>
-                                  </p:childTnLst>
-                                </p:cTn>
-                              </p:par>
-                            </p:childTnLst>
-                          </p:cTn>
-                        </p:par>
-                      </p:childTnLst>
-                    </p:cTn>
-                  </p:par>
-                  <p:par>
-                    <p:cTn id="8" fill="hold">
-                      <p:stCondLst>
-                        <p:cond delay="indefinite"/>
-                      </p:stCondLst>
-                      <p:childTnLst>
-                        <p:par>
-                          <p:cTn id="9" fill="hold">
-                            <p:stCondLst>
-                              <p:cond delay="0"/>
-                            </p:stCondLst>
-                            <p:childTnLst>
-                              <p:par>
-                                <p:cTn id="10" presetID="22" presetClass="entr" presetSubtype="4" fill="hold" nodeType="clickEffect">
-                                  <p:stCondLst>
-                                    <p:cond delay="0"/>
-                                  </p:stCondLst>
-                                  <p:childTnLst>
-                                    <p:set>
-                                      <p:cBhvr>
-                                        <p:cTn id="11" dur="1" fill="hold">
-                                          <p:stCondLst>
-                                            <p:cond delay="0"/>
-                                          </p:stCondLst>
-                                        </p:cTn>
-                                        <p:tgtEl>
-                                          <p:spTgt spid="8"/>
-                                        </p:tgtEl>
-                                        <p:attrNameLst>
-                                          <p:attrName>style.visibility</p:attrName>
-                                        </p:attrNameLst>
-                                      </p:cBhvr>
-                                      <p:to>
-                                        <p:strVal val="visible"/>
-                                      </p:to>
-                                    </p:set>
-                                    <p:animEffect transition="in" filter="wipe(down)">
-                                      <p:cBhvr>
-                                        <p:cTn id="12" dur="500"/>
-                                        <p:tgtEl>
-                                          <p:spTgt spid="8"/>
-                                        </p:tgtEl>
-                                      </p:cBhvr>
-                                    </p:animEffect>
-                                  </p:childTnLst>
-                                </p:cTn>
-                              </p:par>
-                            </p:childTnLst>
-                          </p:cTn>
-                        </p:par>
-                      </p:childTnLst>
-                    </p:cTn>
-                  </p:par>
-                  <p:par>
-                    <p:cTn id="13" fill="hold">
-                      <p:stCondLst>
-                        <p:cond delay="indefinite"/>
-                      </p:stCondLst>
-                      <p:childTnLst>
-                        <p:par>
-                          <p:cTn id="14" fill="hold">
-                            <p:stCondLst>
-                              <p:cond delay="0"/>
-                            </p:stCondLst>
-                            <p:childTnLst>
-                              <p:par>
-                                <p:cTn id="15" presetID="22" presetClass="entr" presetSubtype="4" fill="hold" nodeType="clickEffect">
-                                  <p:stCondLst>
-                                    <p:cond delay="0"/>
-                                  </p:stCondLst>
-                                  <p:childTnLst>
-                                    <p:set>
-                                      <p:cBhvr>
-                                        <p:cTn id="16" dur="1" fill="hold">
-                                          <p:stCondLst>
-                                            <p:cond delay="0"/>
-                                          </p:stCondLst>
-                                        </p:cTn>
-                                        <p:tgtEl>
-                                          <p:spTgt spid="5"/>
-                                        </p:tgtEl>
-                                        <p:attrNameLst>
-                                          <p:attrName>style.visibility</p:attrName>
-                                        </p:attrNameLst>
-                                      </p:cBhvr>
-                                      <p:to>
-                                        <p:strVal val="visible"/>
-                                      </p:to>
-                                    </p:set>
-                                    <p:animEffect transition="in" filter="wipe(down)">
-                                      <p:cBhvr>
-                                        <p:cTn id="17" dur="500"/>
-                                        <p:tgtEl>
-                                          <p:spTgt spid="5"/>
-                                        </p:tgtEl>
-                                      </p:cBhvr>
-                                    </p:animEffect>
-                                  </p:childTnLst>
-                                </p:cTn>
-                              </p:par>
-                            </p:childTnLst>
-                          </p:cTn>
-                        </p:par>
-                      </p:childTnLst>
-                    </p:cTn>
-                  </p:par>
-                  <p:par>
-                    <p:cTn id="18" fill="hold">
-                      <p:stCondLst>
-                        <p:cond delay="indefinite"/>
-                      </p:stCondLst>
-                      <p:childTnLst>
-                        <p:par>
-                          <p:cTn id="19" fill="hold">
-                            <p:stCondLst>
-                              <p:cond delay="0"/>
-                            </p:stCondLst>
-                            <p:childTnLst>
-                              <p:par>
-                                <p:cTn id="20" presetID="22" presetClass="entr" presetSubtype="4" fill="hold" nodeType="clickEffect">
-                                  <p:stCondLst>
-                                    <p:cond delay="0"/>
-                                  </p:stCondLst>
-                                  <p:childTnLst>
-                                    <p:set>
-                                      <p:cBhvr>
-                                        <p:cTn id="21" dur="1" fill="hold">
-                                          <p:stCondLst>
-                                            <p:cond delay="0"/>
-                                          </p:stCondLst>
-                                        </p:cTn>
-                                        <p:tgtEl>
-                                          <p:spTgt spid="12"/>
-                                        </p:tgtEl>
-                                        <p:attrNameLst>
-                                          <p:attrName>style.visibility</p:attrName>
-                                        </p:attrNameLst>
-                                      </p:cBhvr>
-                                      <p:to>
-                                        <p:strVal val="visible"/>
-                                      </p:to>
-                                    </p:set>
-                                    <p:animEffect transition="in" filter="wipe(down)">
-                                      <p:cBhvr>
-                                        <p:cTn id="22" dur="500"/>
-                                        <p:tgtEl>
-                                          <p:spTgt spid="12"/>
-                                        </p:tgtEl>
-                                      </p:cBhvr>
-                                    </p:animEffect>
-                                  </p:childTnLst>
-                                </p:cTn>
-                              </p:par>
-                            </p:childTnLst>
-                          </p:cTn>
-                        </p:par>
-                      </p:childTnLst>
-                    </p:cTn>
-                  </p:par>
-                  <p:par>
-                    <p:cTn id="23" fill="hold">
-                      <p:stCondLst>
-                        <p:cond delay="indefinite"/>
-                      </p:stCondLst>
-                      <p:childTnLst>
-                        <p:par>
-                          <p:cTn id="24" fill="hold">
-                            <p:stCondLst>
-                              <p:cond delay="0"/>
-                            </p:stCondLst>
-                            <p:childTnLst>
-                              <p:par>
-                                <p:cTn id="25" presetID="20" presetClass="entr" presetSubtype="0" fill="hold" nodeType="clickEffect">
-                                  <p:stCondLst>
-                                    <p:cond delay="0"/>
-                                  </p:stCondLst>
-                                  <p:childTnLst>
-                                    <p:set>
-                                      <p:cBhvr>
-                                        <p:cTn id="26" dur="1" fill="hold">
-                                          <p:stCondLst>
-                                            <p:cond delay="0"/>
-                                          </p:stCondLst>
-                                        </p:cTn>
-                                        <p:tgtEl>
-                                          <p:spTgt spid="3"/>
-                                        </p:tgtEl>
-                                        <p:attrNameLst>
-                                          <p:attrName>style.visibility</p:attrName>
-                                        </p:attrNameLst>
-                                      </p:cBhvr>
-                                      <p:to>
-                                        <p:strVal val="visible"/>
-                                      </p:to>
-                                    </p:set>
-                                    <p:animEffect transition="in" filter="wedge">
-                                      <p:cBhvr>
-                                        <p:cTn id="27" dur="2000"/>
-                                        <p:tgtEl>
-                                          <p:spTgt spid="3"/>
-                                        </p:tgtEl>
-                                      </p:cBhvr>
-                                    </p:animEffect>
-                                  </p:childTnLst>
-                                </p:cTn>
-                              </p:par>
-                            </p:childTnLst>
-                          </p:cTn>
-                        </p:par>
-                      </p:childTnLst>
-                    </p:cTn>
-                  </p:par>
-                </p:childTnLst>
-              </p:cTn>
-              <p:prevCondLst>
-                <p:cond evt="onPrev" delay="0">
-                  <p:tgtEl>
-                    <p:sldTgt/>
-                  </p:tgtEl>
-                </p:cond>
-              </p:prevCondLst>
-              <p:nextCondLst>
-                <p:cond evt="onNext" delay="0">
-                  <p:tgtEl>
-                    <p:sldTgt/>
-                  </p:tgtEl>
-                </p:cond>
-              </p:nextCondLst>
-            </p:seq>
-          </p:childTnLst>
-        </p:cTn>
-      </p:par>
-    </p:tnLst>
-  </p:timing>
-</p:sld>
-</file>
-
-<file path=ppt/slides/slide30.xml><?xml version="1.0" encoding="utf-8"?>
+<file path=ppt/slides/slide32.xml><?xml version="1.0" encoding="utf-8"?>
 <p:sld xmlns:a="http://schemas.openxmlformats.org/drawingml/2006/main" xmlns:r="http://schemas.openxmlformats.org/officeDocument/2006/relationships" xmlns:p="http://schemas.openxmlformats.org/presentationml/2006/main" show="0">
   <p:cSld>
     <p:spTree>
@@ -35508,7 +36918,7 @@
 </p:sld>
 </file>
 
-<file path=ppt/slides/slide31.xml><?xml version="1.0" encoding="utf-8"?>
+<file path=ppt/slides/slide33.xml><?xml version="1.0" encoding="utf-8"?>
 <p:sld xmlns:a="http://schemas.openxmlformats.org/drawingml/2006/main" xmlns:r="http://schemas.openxmlformats.org/officeDocument/2006/relationships" xmlns:p="http://schemas.openxmlformats.org/presentationml/2006/main">
   <p:cSld>
     <p:spTree>
@@ -36674,7 +38084,7 @@
 </p:sld>
 </file>
 
-<file path=ppt/slides/slide32.xml><?xml version="1.0" encoding="utf-8"?>
+<file path=ppt/slides/slide34.xml><?xml version="1.0" encoding="utf-8"?>
 <p:sld xmlns:a="http://schemas.openxmlformats.org/drawingml/2006/main" xmlns:r="http://schemas.openxmlformats.org/officeDocument/2006/relationships" xmlns:p="http://schemas.openxmlformats.org/presentationml/2006/main">
   <p:cSld>
     <p:spTree>

</xml_diff>